<commit_message>
update cjsj figure deck
Co-authored-by: Cursor <cursoragent@cursor.com>
</commit_message>
<xml_diff>
--- a/submissions/cjsj/PrakashArjun_figures.pptx
+++ b/submissions/cjsj/PrakashArjun_figures.pptx
@@ -1,23 +1,23 @@
 
 <file path=ppt/presentation.xml><?xml version="1.0" encoding="utf-8"?>
-<p:presentation xmlns:a="http://schemas.openxmlformats.org/drawingml/2006/main" xmlns:r="http://schemas.openxmlformats.org/officeDocument/2006/relationships" xmlns:mc="http://schemas.openxmlformats.org/markup-compatibility/2006" xmlns:mv="urn:schemas-microsoft-com:mac:vml" xmlns:p="http://schemas.openxmlformats.org/presentationml/2006/main" xmlns:c="http://schemas.openxmlformats.org/drawingml/2006/chart" xmlns:dgm="http://schemas.openxmlformats.org/drawingml/2006/diagram" xmlns:o="urn:schemas-microsoft-com:office:office" xmlns:v="urn:schemas-microsoft-com:vml" xmlns:pvml="urn:schemas-microsoft-com:office:powerpoint" xmlns:com="http://schemas.openxmlformats.org/drawingml/2006/compatibility" xmlns:p14="http://schemas.microsoft.com/office/powerpoint/2010/main" xmlns:p15="http://schemas.microsoft.com/office/powerpoint/2012/main" xmlns:ahyp="http://schemas.microsoft.com/office/drawing/2018/hyperlinkcolor" autoCompressPictures="0" strictFirstAndLastChars="0" saveSubsetFonts="1">
+<p:presentation xmlns:a="http://schemas.openxmlformats.org/drawingml/2006/main" xmlns:r="http://schemas.openxmlformats.org/officeDocument/2006/relationships" xmlns:p="http://schemas.openxmlformats.org/presentationml/2006/main" strictFirstAndLastChars="0" saveSubsetFonts="1" autoCompressPictures="0">
   <p:sldMasterIdLst>
-    <p:sldMasterId id="2147483659" r:id="rId4"/>
+    <p:sldMasterId id="2147483659" r:id="rId1"/>
   </p:sldMasterIdLst>
   <p:notesMasterIdLst>
-    <p:notesMasterId r:id="rId5"/>
+    <p:notesMasterId r:id="rId7"/>
   </p:notesMasterIdLst>
   <p:sldIdLst>
-    <p:sldId id="256" r:id="rId6"/>
-    <p:sldId id="257" r:id="rId7"/>
-    <p:sldId id="259" r:id="rId9"/>
-    <p:sldId id="260" r:id="rId10"/>
-    <p:sldId id="261" r:id="rId11"/>
+    <p:sldId id="256" r:id="rId2"/>
+    <p:sldId id="257" r:id="rId3"/>
+    <p:sldId id="259" r:id="rId4"/>
+    <p:sldId id="260" r:id="rId5"/>
+    <p:sldId id="261" r:id="rId6"/>
   </p:sldIdLst>
-  <p:sldSz cy="5143500" cx="9144000"/>
+  <p:sldSz cx="9144000" cy="5143500" type="screen16x9"/>
   <p:notesSz cx="6858000" cy="9144000"/>
   <p:defaultTextStyle>
-    <a:defPPr lvl="0" marR="0" rtl="0" algn="l">
+    <a:defPPr marR="0" lvl="0" algn="l" rtl="0">
       <a:lnSpc>
         <a:spcPct val="100000"/>
       </a:lnSpc>
@@ -28,7 +28,7 @@
         <a:spcPts val="0"/>
       </a:spcAft>
     </a:defPPr>
-    <a:lvl1pPr lvl="0" marR="0" rtl="0" algn="l">
+    <a:lvl1pPr marR="0" lvl="0" algn="l" rtl="0">
       <a:lnSpc>
         <a:spcPct val="100000"/>
       </a:lnSpc>
@@ -42,7 +42,7 @@
         <a:srgbClr val="000000"/>
       </a:buClr>
       <a:buFont typeface="Arial"/>
-      <a:defRPr b="0" i="0" sz="1400" u="none" cap="none" strike="noStrike">
+      <a:defRPr sz="1400" b="0" i="0" u="none" strike="noStrike" cap="none">
         <a:solidFill>
           <a:srgbClr val="000000"/>
         </a:solidFill>
@@ -52,7 +52,7 @@
         <a:sym typeface="Arial"/>
       </a:defRPr>
     </a:lvl1pPr>
-    <a:lvl2pPr lvl="1" marR="0" rtl="0" algn="l">
+    <a:lvl2pPr marR="0" lvl="1" algn="l" rtl="0">
       <a:lnSpc>
         <a:spcPct val="100000"/>
       </a:lnSpc>
@@ -66,7 +66,7 @@
         <a:srgbClr val="000000"/>
       </a:buClr>
       <a:buFont typeface="Arial"/>
-      <a:defRPr b="0" i="0" sz="1400" u="none" cap="none" strike="noStrike">
+      <a:defRPr sz="1400" b="0" i="0" u="none" strike="noStrike" cap="none">
         <a:solidFill>
           <a:srgbClr val="000000"/>
         </a:solidFill>
@@ -76,7 +76,7 @@
         <a:sym typeface="Arial"/>
       </a:defRPr>
     </a:lvl2pPr>
-    <a:lvl3pPr lvl="2" marR="0" rtl="0" algn="l">
+    <a:lvl3pPr marR="0" lvl="2" algn="l" rtl="0">
       <a:lnSpc>
         <a:spcPct val="100000"/>
       </a:lnSpc>
@@ -90,7 +90,7 @@
         <a:srgbClr val="000000"/>
       </a:buClr>
       <a:buFont typeface="Arial"/>
-      <a:defRPr b="0" i="0" sz="1400" u="none" cap="none" strike="noStrike">
+      <a:defRPr sz="1400" b="0" i="0" u="none" strike="noStrike" cap="none">
         <a:solidFill>
           <a:srgbClr val="000000"/>
         </a:solidFill>
@@ -100,7 +100,7 @@
         <a:sym typeface="Arial"/>
       </a:defRPr>
     </a:lvl3pPr>
-    <a:lvl4pPr lvl="3" marR="0" rtl="0" algn="l">
+    <a:lvl4pPr marR="0" lvl="3" algn="l" rtl="0">
       <a:lnSpc>
         <a:spcPct val="100000"/>
       </a:lnSpc>
@@ -114,7 +114,7 @@
         <a:srgbClr val="000000"/>
       </a:buClr>
       <a:buFont typeface="Arial"/>
-      <a:defRPr b="0" i="0" sz="1400" u="none" cap="none" strike="noStrike">
+      <a:defRPr sz="1400" b="0" i="0" u="none" strike="noStrike" cap="none">
         <a:solidFill>
           <a:srgbClr val="000000"/>
         </a:solidFill>
@@ -124,7 +124,7 @@
         <a:sym typeface="Arial"/>
       </a:defRPr>
     </a:lvl4pPr>
-    <a:lvl5pPr lvl="4" marR="0" rtl="0" algn="l">
+    <a:lvl5pPr marR="0" lvl="4" algn="l" rtl="0">
       <a:lnSpc>
         <a:spcPct val="100000"/>
       </a:lnSpc>
@@ -138,7 +138,7 @@
         <a:srgbClr val="000000"/>
       </a:buClr>
       <a:buFont typeface="Arial"/>
-      <a:defRPr b="0" i="0" sz="1400" u="none" cap="none" strike="noStrike">
+      <a:defRPr sz="1400" b="0" i="0" u="none" strike="noStrike" cap="none">
         <a:solidFill>
           <a:srgbClr val="000000"/>
         </a:solidFill>
@@ -148,7 +148,7 @@
         <a:sym typeface="Arial"/>
       </a:defRPr>
     </a:lvl5pPr>
-    <a:lvl6pPr lvl="5" marR="0" rtl="0" algn="l">
+    <a:lvl6pPr marR="0" lvl="5" algn="l" rtl="0">
       <a:lnSpc>
         <a:spcPct val="100000"/>
       </a:lnSpc>
@@ -162,7 +162,7 @@
         <a:srgbClr val="000000"/>
       </a:buClr>
       <a:buFont typeface="Arial"/>
-      <a:defRPr b="0" i="0" sz="1400" u="none" cap="none" strike="noStrike">
+      <a:defRPr sz="1400" b="0" i="0" u="none" strike="noStrike" cap="none">
         <a:solidFill>
           <a:srgbClr val="000000"/>
         </a:solidFill>
@@ -172,7 +172,7 @@
         <a:sym typeface="Arial"/>
       </a:defRPr>
     </a:lvl6pPr>
-    <a:lvl7pPr lvl="6" marR="0" rtl="0" algn="l">
+    <a:lvl7pPr marR="0" lvl="6" algn="l" rtl="0">
       <a:lnSpc>
         <a:spcPct val="100000"/>
       </a:lnSpc>
@@ -186,7 +186,7 @@
         <a:srgbClr val="000000"/>
       </a:buClr>
       <a:buFont typeface="Arial"/>
-      <a:defRPr b="0" i="0" sz="1400" u="none" cap="none" strike="noStrike">
+      <a:defRPr sz="1400" b="0" i="0" u="none" strike="noStrike" cap="none">
         <a:solidFill>
           <a:srgbClr val="000000"/>
         </a:solidFill>
@@ -196,7 +196,7 @@
         <a:sym typeface="Arial"/>
       </a:defRPr>
     </a:lvl7pPr>
-    <a:lvl8pPr lvl="7" marR="0" rtl="0" algn="l">
+    <a:lvl8pPr marR="0" lvl="7" algn="l" rtl="0">
       <a:lnSpc>
         <a:spcPct val="100000"/>
       </a:lnSpc>
@@ -210,7 +210,7 @@
         <a:srgbClr val="000000"/>
       </a:buClr>
       <a:buFont typeface="Arial"/>
-      <a:defRPr b="0" i="0" sz="1400" u="none" cap="none" strike="noStrike">
+      <a:defRPr sz="1400" b="0" i="0" u="none" strike="noStrike" cap="none">
         <a:solidFill>
           <a:srgbClr val="000000"/>
         </a:solidFill>
@@ -220,7 +220,7 @@
         <a:sym typeface="Arial"/>
       </a:defRPr>
     </a:lvl8pPr>
-    <a:lvl9pPr lvl="8" marR="0" rtl="0" algn="l">
+    <a:lvl9pPr marR="0" lvl="8" algn="l" rtl="0">
       <a:lnSpc>
         <a:spcPct val="100000"/>
       </a:lnSpc>
@@ -234,7 +234,7 @@
         <a:srgbClr val="000000"/>
       </a:buClr>
       <a:buFont typeface="Arial"/>
-      <a:defRPr b="0" i="0" sz="1400" u="none" cap="none" strike="noStrike">
+      <a:defRPr sz="1400" b="0" i="0" u="none" strike="noStrike" cap="none">
         <a:solidFill>
           <a:srgbClr val="000000"/>
         </a:solidFill>
@@ -247,7 +247,7 @@
   </p:defaultTextStyle>
   <p:extLst>
     <p:ext uri="{EFAFB233-063F-42B5-8137-9DF3F51BA10A}">
-      <p15:sldGuideLst>
+      <p15:sldGuideLst xmlns:p15="http://schemas.microsoft.com/office/powerpoint/2012/main">
         <p15:guide id="1" orient="horz" pos="1620">
           <p15:clr>
             <a:srgbClr val="747775"/>
@@ -265,11 +265,16 @@
 </file>
 
 <file path=ppt/notesMasters/notesMaster1.xml><?xml version="1.0" encoding="utf-8"?>
-<p:notesMaster xmlns:a="http://schemas.openxmlformats.org/drawingml/2006/main" xmlns:r="http://schemas.openxmlformats.org/officeDocument/2006/relationships" xmlns:mc="http://schemas.openxmlformats.org/markup-compatibility/2006" xmlns:mv="urn:schemas-microsoft-com:mac:vml" xmlns:p="http://schemas.openxmlformats.org/presentationml/2006/main" xmlns:c="http://schemas.openxmlformats.org/drawingml/2006/chart" xmlns:dgm="http://schemas.openxmlformats.org/drawingml/2006/diagram" xmlns:o="urn:schemas-microsoft-com:office:office" xmlns:v="urn:schemas-microsoft-com:vml" xmlns:pvml="urn:schemas-microsoft-com:office:powerpoint" xmlns:com="http://schemas.openxmlformats.org/drawingml/2006/compatibility" xmlns:p14="http://schemas.microsoft.com/office/powerpoint/2010/main" xmlns:p15="http://schemas.microsoft.com/office/powerpoint/2012/main" xmlns:ahyp="http://schemas.microsoft.com/office/drawing/2018/hyperlinkcolor">
+<p:notesMaster xmlns:a="http://schemas.openxmlformats.org/drawingml/2006/main" xmlns:r="http://schemas.openxmlformats.org/officeDocument/2006/relationships" xmlns:p="http://schemas.openxmlformats.org/presentationml/2006/main">
   <p:cSld>
+    <p:bg>
+      <p:bgRef idx="1001">
+        <a:schemeClr val="bg1"/>
+      </p:bgRef>
+    </p:bg>
     <p:spTree>
       <p:nvGrpSpPr>
-        <p:cNvPr id="2" name="Shape 2"/>
+        <p:cNvPr id="1" name="Shape 2"/>
         <p:cNvGrpSpPr/>
         <p:nvPr/>
       </p:nvGrpSpPr>
@@ -284,9 +289,11 @@
       <p:sp>
         <p:nvSpPr>
           <p:cNvPr id="3" name="Google Shape;3;n"/>
-          <p:cNvSpPr/>
+          <p:cNvSpPr>
+            <a:spLocks noGrp="1" noRot="1" noChangeAspect="1"/>
+          </p:cNvSpPr>
           <p:nvPr>
-            <p:ph idx="2" type="sldImg"/>
+            <p:ph type="sldImg" idx="2"/>
           </p:nvPr>
         </p:nvSpPr>
         <p:spPr>
@@ -295,9 +302,13 @@
             <a:ext cx="6096075" cy="3429000"/>
           </a:xfrm>
           <a:custGeom>
-            <a:rect b="b" l="l" r="r" t="t"/>
+            <a:avLst/>
+            <a:gdLst/>
+            <a:ahLst/>
+            <a:cxnLst/>
+            <a:rect l="l" t="t" r="r" b="b"/>
             <a:pathLst>
-              <a:path extrusionOk="0" h="120000" w="120000">
+              <a:path w="120000" h="120000" extrusionOk="0">
                 <a:moveTo>
                   <a:pt x="0" y="0"/>
                 </a:moveTo>
@@ -315,23 +326,25 @@
             </a:pathLst>
           </a:custGeom>
           <a:noFill/>
-          <a:ln cap="flat" cmpd="sng" w="9525">
+          <a:ln w="9525" cap="flat" cmpd="sng">
             <a:solidFill>
               <a:srgbClr val="000000"/>
             </a:solidFill>
             <a:prstDash val="solid"/>
             <a:round/>
-            <a:headEnd len="sm" w="sm" type="none"/>
-            <a:tailEnd len="sm" w="sm" type="none"/>
+            <a:headEnd type="none" w="sm" len="sm"/>
+            <a:tailEnd type="none" w="sm" len="sm"/>
           </a:ln>
         </p:spPr>
       </p:sp>
       <p:sp>
         <p:nvSpPr>
           <p:cNvPr id="4" name="Google Shape;4;n"/>
-          <p:cNvSpPr txBox="1"/>
+          <p:cNvSpPr txBox="1">
+            <a:spLocks noGrp="1"/>
+          </p:cNvSpPr>
           <p:nvPr>
-            <p:ph idx="1" type="body"/>
+            <p:ph type="body" idx="1"/>
           </p:nvPr>
         </p:nvSpPr>
         <p:spPr>
@@ -348,11 +361,11 @@
           </a:ln>
         </p:spPr>
         <p:txBody>
-          <a:bodyPr anchorCtr="0" anchor="t" bIns="91425" lIns="91425" spcFirstLastPara="1" rIns="91425" wrap="square" tIns="91425">
+          <a:bodyPr spcFirstLastPara="1" wrap="square" lIns="91425" tIns="91425" rIns="91425" bIns="91425" anchor="t" anchorCtr="0">
             <a:noAutofit/>
           </a:bodyPr>
           <a:lstStyle>
-            <a:lvl1pPr indent="-298450" lvl="0" marL="457200">
+            <a:lvl1pPr marL="457200" lvl="0" indent="-298450">
               <a:spcBef>
                 <a:spcPts val="0"/>
               </a:spcBef>
@@ -363,7 +376,7 @@
               <a:buChar char="●"/>
               <a:defRPr sz="1100"/>
             </a:lvl1pPr>
-            <a:lvl2pPr indent="-298450" lvl="1" marL="914400">
+            <a:lvl2pPr marL="914400" lvl="1" indent="-298450">
               <a:spcBef>
                 <a:spcPts val="0"/>
               </a:spcBef>
@@ -374,7 +387,7 @@
               <a:buChar char="○"/>
               <a:defRPr sz="1100"/>
             </a:lvl2pPr>
-            <a:lvl3pPr indent="-298450" lvl="2" marL="1371600">
+            <a:lvl3pPr marL="1371600" lvl="2" indent="-298450">
               <a:spcBef>
                 <a:spcPts val="0"/>
               </a:spcBef>
@@ -385,7 +398,7 @@
               <a:buChar char="■"/>
               <a:defRPr sz="1100"/>
             </a:lvl3pPr>
-            <a:lvl4pPr indent="-298450" lvl="3" marL="1828800">
+            <a:lvl4pPr marL="1828800" lvl="3" indent="-298450">
               <a:spcBef>
                 <a:spcPts val="0"/>
               </a:spcBef>
@@ -396,7 +409,7 @@
               <a:buChar char="●"/>
               <a:defRPr sz="1100"/>
             </a:lvl4pPr>
-            <a:lvl5pPr indent="-298450" lvl="4" marL="2286000">
+            <a:lvl5pPr marL="2286000" lvl="4" indent="-298450">
               <a:spcBef>
                 <a:spcPts val="0"/>
               </a:spcBef>
@@ -407,7 +420,7 @@
               <a:buChar char="○"/>
               <a:defRPr sz="1100"/>
             </a:lvl5pPr>
-            <a:lvl6pPr indent="-298450" lvl="5" marL="2743200">
+            <a:lvl6pPr marL="2743200" lvl="5" indent="-298450">
               <a:spcBef>
                 <a:spcPts val="0"/>
               </a:spcBef>
@@ -418,7 +431,7 @@
               <a:buChar char="■"/>
               <a:defRPr sz="1100"/>
             </a:lvl6pPr>
-            <a:lvl7pPr indent="-298450" lvl="6" marL="3200400">
+            <a:lvl7pPr marL="3200400" lvl="6" indent="-298450">
               <a:spcBef>
                 <a:spcPts val="0"/>
               </a:spcBef>
@@ -429,7 +442,7 @@
               <a:buChar char="●"/>
               <a:defRPr sz="1100"/>
             </a:lvl7pPr>
-            <a:lvl8pPr indent="-298450" lvl="7" marL="3657600">
+            <a:lvl8pPr marL="3657600" lvl="7" indent="-298450">
               <a:spcBef>
                 <a:spcPts val="0"/>
               </a:spcBef>
@@ -440,7 +453,7 @@
               <a:buChar char="○"/>
               <a:defRPr sz="1100"/>
             </a:lvl8pPr>
-            <a:lvl9pPr indent="-298450" lvl="8" marL="4114800">
+            <a:lvl9pPr marL="4114800" lvl="8" indent="-298450">
               <a:spcBef>
                 <a:spcPts val="0"/>
               </a:spcBef>
@@ -452,14 +465,16 @@
               <a:defRPr sz="1100"/>
             </a:lvl9pPr>
           </a:lstStyle>
-          <a:p/>
+          <a:p>
+            <a:endParaRPr/>
+          </a:p>
         </p:txBody>
       </p:sp>
     </p:spTree>
   </p:cSld>
-  <p:clrMap accent1="accent1" accent2="accent2" accent3="accent3" accent4="accent4" accent5="accent5" accent6="accent6" bg1="lt1" bg2="dk2" tx1="dk1" tx2="lt2" folHlink="folHlink" hlink="hlink"/>
+  <p:clrMap bg1="lt1" tx1="dk1" bg2="dk2" tx2="lt2" accent1="accent1" accent2="accent2" accent3="accent3" accent4="accent4" accent5="accent5" accent6="accent6" hlink="hlink" folHlink="folHlink"/>
   <p:notesStyle>
-    <a:defPPr lvl="0" marR="0" rtl="0" algn="l">
+    <a:defPPr marR="0" lvl="0" algn="l" rtl="0">
       <a:lnSpc>
         <a:spcPct val="100000"/>
       </a:lnSpc>
@@ -470,7 +485,7 @@
         <a:spcPts val="0"/>
       </a:spcAft>
     </a:defPPr>
-    <a:lvl1pPr lvl="0" marR="0" rtl="0" algn="l">
+    <a:lvl1pPr marR="0" lvl="0" algn="l" rtl="0">
       <a:lnSpc>
         <a:spcPct val="100000"/>
       </a:lnSpc>
@@ -484,7 +499,7 @@
         <a:srgbClr val="000000"/>
       </a:buClr>
       <a:buFont typeface="Arial"/>
-      <a:defRPr b="0" i="0" sz="1400" u="none" cap="none" strike="noStrike">
+      <a:defRPr sz="1400" b="0" i="0" u="none" strike="noStrike" cap="none">
         <a:solidFill>
           <a:srgbClr val="000000"/>
         </a:solidFill>
@@ -494,7 +509,7 @@
         <a:sym typeface="Arial"/>
       </a:defRPr>
     </a:lvl1pPr>
-    <a:lvl2pPr lvl="1" marR="0" rtl="0" algn="l">
+    <a:lvl2pPr marR="0" lvl="1" algn="l" rtl="0">
       <a:lnSpc>
         <a:spcPct val="100000"/>
       </a:lnSpc>
@@ -508,7 +523,7 @@
         <a:srgbClr val="000000"/>
       </a:buClr>
       <a:buFont typeface="Arial"/>
-      <a:defRPr b="0" i="0" sz="1400" u="none" cap="none" strike="noStrike">
+      <a:defRPr sz="1400" b="0" i="0" u="none" strike="noStrike" cap="none">
         <a:solidFill>
           <a:srgbClr val="000000"/>
         </a:solidFill>
@@ -518,7 +533,7 @@
         <a:sym typeface="Arial"/>
       </a:defRPr>
     </a:lvl2pPr>
-    <a:lvl3pPr lvl="2" marR="0" rtl="0" algn="l">
+    <a:lvl3pPr marR="0" lvl="2" algn="l" rtl="0">
       <a:lnSpc>
         <a:spcPct val="100000"/>
       </a:lnSpc>
@@ -532,7 +547,7 @@
         <a:srgbClr val="000000"/>
       </a:buClr>
       <a:buFont typeface="Arial"/>
-      <a:defRPr b="0" i="0" sz="1400" u="none" cap="none" strike="noStrike">
+      <a:defRPr sz="1400" b="0" i="0" u="none" strike="noStrike" cap="none">
         <a:solidFill>
           <a:srgbClr val="000000"/>
         </a:solidFill>
@@ -542,7 +557,7 @@
         <a:sym typeface="Arial"/>
       </a:defRPr>
     </a:lvl3pPr>
-    <a:lvl4pPr lvl="3" marR="0" rtl="0" algn="l">
+    <a:lvl4pPr marR="0" lvl="3" algn="l" rtl="0">
       <a:lnSpc>
         <a:spcPct val="100000"/>
       </a:lnSpc>
@@ -556,7 +571,7 @@
         <a:srgbClr val="000000"/>
       </a:buClr>
       <a:buFont typeface="Arial"/>
-      <a:defRPr b="0" i="0" sz="1400" u="none" cap="none" strike="noStrike">
+      <a:defRPr sz="1400" b="0" i="0" u="none" strike="noStrike" cap="none">
         <a:solidFill>
           <a:srgbClr val="000000"/>
         </a:solidFill>
@@ -566,7 +581,7 @@
         <a:sym typeface="Arial"/>
       </a:defRPr>
     </a:lvl4pPr>
-    <a:lvl5pPr lvl="4" marR="0" rtl="0" algn="l">
+    <a:lvl5pPr marR="0" lvl="4" algn="l" rtl="0">
       <a:lnSpc>
         <a:spcPct val="100000"/>
       </a:lnSpc>
@@ -580,7 +595,7 @@
         <a:srgbClr val="000000"/>
       </a:buClr>
       <a:buFont typeface="Arial"/>
-      <a:defRPr b="0" i="0" sz="1400" u="none" cap="none" strike="noStrike">
+      <a:defRPr sz="1400" b="0" i="0" u="none" strike="noStrike" cap="none">
         <a:solidFill>
           <a:srgbClr val="000000"/>
         </a:solidFill>
@@ -590,7 +605,7 @@
         <a:sym typeface="Arial"/>
       </a:defRPr>
     </a:lvl5pPr>
-    <a:lvl6pPr lvl="5" marR="0" rtl="0" algn="l">
+    <a:lvl6pPr marR="0" lvl="5" algn="l" rtl="0">
       <a:lnSpc>
         <a:spcPct val="100000"/>
       </a:lnSpc>
@@ -604,7 +619,7 @@
         <a:srgbClr val="000000"/>
       </a:buClr>
       <a:buFont typeface="Arial"/>
-      <a:defRPr b="0" i="0" sz="1400" u="none" cap="none" strike="noStrike">
+      <a:defRPr sz="1400" b="0" i="0" u="none" strike="noStrike" cap="none">
         <a:solidFill>
           <a:srgbClr val="000000"/>
         </a:solidFill>
@@ -614,7 +629,7 @@
         <a:sym typeface="Arial"/>
       </a:defRPr>
     </a:lvl6pPr>
-    <a:lvl7pPr lvl="6" marR="0" rtl="0" algn="l">
+    <a:lvl7pPr marR="0" lvl="6" algn="l" rtl="0">
       <a:lnSpc>
         <a:spcPct val="100000"/>
       </a:lnSpc>
@@ -628,7 +643,7 @@
         <a:srgbClr val="000000"/>
       </a:buClr>
       <a:buFont typeface="Arial"/>
-      <a:defRPr b="0" i="0" sz="1400" u="none" cap="none" strike="noStrike">
+      <a:defRPr sz="1400" b="0" i="0" u="none" strike="noStrike" cap="none">
         <a:solidFill>
           <a:srgbClr val="000000"/>
         </a:solidFill>
@@ -638,7 +653,7 @@
         <a:sym typeface="Arial"/>
       </a:defRPr>
     </a:lvl7pPr>
-    <a:lvl8pPr lvl="7" marR="0" rtl="0" algn="l">
+    <a:lvl8pPr marR="0" lvl="7" algn="l" rtl="0">
       <a:lnSpc>
         <a:spcPct val="100000"/>
       </a:lnSpc>
@@ -652,7 +667,7 @@
         <a:srgbClr val="000000"/>
       </a:buClr>
       <a:buFont typeface="Arial"/>
-      <a:defRPr b="0" i="0" sz="1400" u="none" cap="none" strike="noStrike">
+      <a:defRPr sz="1400" b="0" i="0" u="none" strike="noStrike" cap="none">
         <a:solidFill>
           <a:srgbClr val="000000"/>
         </a:solidFill>
@@ -662,7 +677,7 @@
         <a:sym typeface="Arial"/>
       </a:defRPr>
     </a:lvl8pPr>
-    <a:lvl9pPr lvl="8" marR="0" rtl="0" algn="l">
+    <a:lvl9pPr marR="0" lvl="8" algn="l" rtl="0">
       <a:lnSpc>
         <a:spcPct val="100000"/>
       </a:lnSpc>
@@ -676,7 +691,7 @@
         <a:srgbClr val="000000"/>
       </a:buClr>
       <a:buFont typeface="Arial"/>
-      <a:defRPr b="0" i="0" sz="1400" u="none" cap="none" strike="noStrike">
+      <a:defRPr sz="1400" b="0" i="0" u="none" strike="noStrike" cap="none">
         <a:solidFill>
           <a:srgbClr val="000000"/>
         </a:solidFill>
@@ -691,11 +706,11 @@
 </file>
 
 <file path=ppt/notesSlides/notesSlide1.xml><?xml version="1.0" encoding="utf-8"?>
-<p:notes xmlns:a="http://schemas.openxmlformats.org/drawingml/2006/main" xmlns:r="http://schemas.openxmlformats.org/officeDocument/2006/relationships" xmlns:mc="http://schemas.openxmlformats.org/markup-compatibility/2006" xmlns:mv="urn:schemas-microsoft-com:mac:vml" xmlns:p="http://schemas.openxmlformats.org/presentationml/2006/main" xmlns:c="http://schemas.openxmlformats.org/drawingml/2006/chart" xmlns:dgm="http://schemas.openxmlformats.org/drawingml/2006/diagram" xmlns:o="urn:schemas-microsoft-com:office:office" xmlns:v="urn:schemas-microsoft-com:vml" xmlns:pvml="urn:schemas-microsoft-com:office:powerpoint" xmlns:com="http://schemas.openxmlformats.org/drawingml/2006/compatibility" xmlns:p14="http://schemas.microsoft.com/office/powerpoint/2010/main" xmlns:p15="http://schemas.microsoft.com/office/powerpoint/2012/main" xmlns:ahyp="http://schemas.microsoft.com/office/drawing/2018/hyperlinkcolor" showMasterPhAnim="0" showMasterSp="0">
+<p:notes xmlns:a="http://schemas.openxmlformats.org/drawingml/2006/main" xmlns:r="http://schemas.openxmlformats.org/officeDocument/2006/relationships" xmlns:p="http://schemas.openxmlformats.org/presentationml/2006/main" showMasterSp="0" showMasterPhAnim="0">
   <p:cSld>
     <p:spTree>
       <p:nvGrpSpPr>
-        <p:cNvPr id="50" name="Shape 50"/>
+        <p:cNvPr id="1" name="Shape 50"/>
         <p:cNvGrpSpPr/>
         <p:nvPr/>
       </p:nvGrpSpPr>
@@ -710,9 +725,11 @@
       <p:sp>
         <p:nvSpPr>
           <p:cNvPr id="51" name="Google Shape;51;p:notes"/>
-          <p:cNvSpPr/>
+          <p:cNvSpPr>
+            <a:spLocks noGrp="1" noRot="1" noChangeAspect="1"/>
+          </p:cNvSpPr>
           <p:nvPr>
-            <p:ph idx="2" type="sldImg"/>
+            <p:ph type="sldImg" idx="2"/>
           </p:nvPr>
         </p:nvSpPr>
         <p:spPr>
@@ -721,9 +738,13 @@
             <a:ext cx="6096075" cy="3429000"/>
           </a:xfrm>
           <a:custGeom>
-            <a:rect b="b" l="l" r="r" t="t"/>
+            <a:avLst/>
+            <a:gdLst/>
+            <a:ahLst/>
+            <a:cxnLst/>
+            <a:rect l="l" t="t" r="r" b="b"/>
             <a:pathLst>
-              <a:path extrusionOk="0" h="120000" w="120000">
+              <a:path w="120000" h="120000" extrusionOk="0">
                 <a:moveTo>
                   <a:pt x="0" y="0"/>
                 </a:moveTo>
@@ -745,9 +766,11 @@
       <p:sp>
         <p:nvSpPr>
           <p:cNvPr id="52" name="Google Shape;52;p:notes"/>
-          <p:cNvSpPr txBox="1"/>
+          <p:cNvSpPr txBox="1">
+            <a:spLocks noGrp="1"/>
+          </p:cNvSpPr>
           <p:nvPr>
-            <p:ph idx="1" type="body"/>
+            <p:ph type="body" idx="1"/>
           </p:nvPr>
         </p:nvSpPr>
         <p:spPr>
@@ -760,12 +783,12 @@
           </a:prstGeom>
         </p:spPr>
         <p:txBody>
-          <a:bodyPr anchorCtr="0" anchor="t" bIns="91425" lIns="91425" spcFirstLastPara="1" rIns="91425" wrap="square" tIns="91425">
+          <a:bodyPr spcFirstLastPara="1" wrap="square" lIns="91425" tIns="91425" rIns="91425" bIns="91425" anchor="t" anchorCtr="0">
             <a:noAutofit/>
           </a:bodyPr>
           <a:lstStyle/>
           <a:p>
-            <a:pPr indent="0" lvl="0" marL="0" rtl="0" algn="l">
+            <a:pPr marL="0" lvl="0" indent="0" algn="l" rtl="0">
               <a:spcBef>
                 <a:spcPts val="0"/>
               </a:spcBef>
@@ -774,9 +797,6 @@
               </a:spcAft>
               <a:buNone/>
             </a:pPr>
-            <a:r>
-              <a:t/>
-            </a:r>
             <a:endParaRPr/>
           </a:p>
         </p:txBody>
@@ -790,11 +810,11 @@
 </file>
 
 <file path=ppt/slideLayouts/slideLayout1.xml><?xml version="1.0" encoding="utf-8"?>
-<p:sldLayout xmlns:a="http://schemas.openxmlformats.org/drawingml/2006/main" xmlns:r="http://schemas.openxmlformats.org/officeDocument/2006/relationships" xmlns:mc="http://schemas.openxmlformats.org/markup-compatibility/2006" xmlns:mv="urn:schemas-microsoft-com:mac:vml" xmlns:p="http://schemas.openxmlformats.org/presentationml/2006/main" xmlns:c="http://schemas.openxmlformats.org/drawingml/2006/chart" xmlns:dgm="http://schemas.openxmlformats.org/drawingml/2006/diagram" xmlns:o="urn:schemas-microsoft-com:office:office" xmlns:v="urn:schemas-microsoft-com:vml" xmlns:pvml="urn:schemas-microsoft-com:office:powerpoint" xmlns:com="http://schemas.openxmlformats.org/drawingml/2006/compatibility" xmlns:p14="http://schemas.microsoft.com/office/powerpoint/2010/main" xmlns:p15="http://schemas.microsoft.com/office/powerpoint/2012/main" xmlns:ahyp="http://schemas.microsoft.com/office/drawing/2018/hyperlinkcolor" matchingName="Title slide" type="title">
+<p:sldLayout xmlns:a="http://schemas.openxmlformats.org/drawingml/2006/main" xmlns:r="http://schemas.openxmlformats.org/officeDocument/2006/relationships" xmlns:p="http://schemas.openxmlformats.org/presentationml/2006/main" matchingName="Title slide" type="title">
   <p:cSld name="TITLE">
     <p:spTree>
       <p:nvGrpSpPr>
-        <p:cNvPr id="9" name="Shape 9"/>
+        <p:cNvPr id="1" name="Shape 9"/>
         <p:cNvGrpSpPr/>
         <p:nvPr/>
       </p:nvGrpSpPr>
@@ -809,7 +829,9 @@
       <p:sp>
         <p:nvSpPr>
           <p:cNvPr id="10" name="Google Shape;10;p2"/>
-          <p:cNvSpPr txBox="1"/>
+          <p:cNvSpPr txBox="1">
+            <a:spLocks noGrp="1"/>
+          </p:cNvSpPr>
           <p:nvPr>
             <p:ph type="ctrTitle"/>
           </p:nvPr>
@@ -824,7 +846,7 @@
           </a:prstGeom>
         </p:spPr>
         <p:txBody>
-          <a:bodyPr anchorCtr="0" anchor="b" bIns="91425" lIns="91425" spcFirstLastPara="1" rIns="91425" wrap="square" tIns="91425">
+          <a:bodyPr spcFirstLastPara="1" wrap="square" lIns="91425" tIns="91425" rIns="91425" bIns="91425" anchor="b" anchorCtr="0">
             <a:normAutofit/>
           </a:bodyPr>
           <a:lstStyle>
@@ -928,15 +950,19 @@
               <a:defRPr sz="5200"/>
             </a:lvl9pPr>
           </a:lstStyle>
-          <a:p/>
+          <a:p>
+            <a:endParaRPr/>
+          </a:p>
         </p:txBody>
       </p:sp>
       <p:sp>
         <p:nvSpPr>
           <p:cNvPr id="11" name="Google Shape;11;p2"/>
-          <p:cNvSpPr txBox="1"/>
+          <p:cNvSpPr txBox="1">
+            <a:spLocks noGrp="1"/>
+          </p:cNvSpPr>
           <p:nvPr>
-            <p:ph idx="1" type="subTitle"/>
+            <p:ph type="subTitle" idx="1"/>
           </p:nvPr>
         </p:nvSpPr>
         <p:spPr>
@@ -949,7 +975,7 @@
           </a:prstGeom>
         </p:spPr>
         <p:txBody>
-          <a:bodyPr anchorCtr="0" anchor="t" bIns="91425" lIns="91425" spcFirstLastPara="1" rIns="91425" wrap="square" tIns="91425">
+          <a:bodyPr spcFirstLastPara="1" wrap="square" lIns="91425" tIns="91425" rIns="91425" bIns="91425" anchor="t" anchorCtr="0">
             <a:normAutofit/>
           </a:bodyPr>
           <a:lstStyle>
@@ -1080,15 +1106,19 @@
               <a:defRPr sz="2800"/>
             </a:lvl9pPr>
           </a:lstStyle>
-          <a:p/>
+          <a:p>
+            <a:endParaRPr/>
+          </a:p>
         </p:txBody>
       </p:sp>
       <p:sp>
         <p:nvSpPr>
           <p:cNvPr id="12" name="Google Shape;12;p2"/>
-          <p:cNvSpPr txBox="1"/>
+          <p:cNvSpPr txBox="1">
+            <a:spLocks noGrp="1"/>
+          </p:cNvSpPr>
           <p:nvPr>
-            <p:ph idx="12" type="sldNum"/>
+            <p:ph type="sldNum" idx="12"/>
           </p:nvPr>
         </p:nvSpPr>
         <p:spPr>
@@ -1101,7 +1131,7 @@
           </a:prstGeom>
         </p:spPr>
         <p:txBody>
-          <a:bodyPr anchorCtr="0" anchor="ctr" bIns="91425" lIns="91425" spcFirstLastPara="1" rIns="91425" wrap="square" tIns="91425">
+          <a:bodyPr spcFirstLastPara="1" wrap="square" lIns="91425" tIns="91425" rIns="91425" bIns="91425" anchor="ctr" anchorCtr="0">
             <a:normAutofit/>
           </a:bodyPr>
           <a:lstStyle>
@@ -1143,7 +1173,7 @@
             </a:lvl9pPr>
           </a:lstStyle>
           <a:p>
-            <a:pPr indent="0" lvl="0" marL="0" rtl="0" algn="r">
+            <a:pPr marL="0" lvl="0" indent="0" algn="r" rtl="0">
               <a:spcBef>
                 <a:spcPts val="0"/>
               </a:spcBef>
@@ -1169,11 +1199,11 @@
 </file>
 
 <file path=ppt/slideLayouts/slideLayout10.xml><?xml version="1.0" encoding="utf-8"?>
-<p:sldLayout xmlns:a="http://schemas.openxmlformats.org/drawingml/2006/main" xmlns:r="http://schemas.openxmlformats.org/officeDocument/2006/relationships" xmlns:mc="http://schemas.openxmlformats.org/markup-compatibility/2006" xmlns:mv="urn:schemas-microsoft-com:mac:vml" xmlns:p="http://schemas.openxmlformats.org/presentationml/2006/main" xmlns:c="http://schemas.openxmlformats.org/drawingml/2006/chart" xmlns:dgm="http://schemas.openxmlformats.org/drawingml/2006/diagram" xmlns:o="urn:schemas-microsoft-com:office:office" xmlns:v="urn:schemas-microsoft-com:vml" xmlns:pvml="urn:schemas-microsoft-com:office:powerpoint" xmlns:com="http://schemas.openxmlformats.org/drawingml/2006/compatibility" xmlns:p14="http://schemas.microsoft.com/office/powerpoint/2010/main" xmlns:p15="http://schemas.microsoft.com/office/powerpoint/2012/main" xmlns:ahyp="http://schemas.microsoft.com/office/drawing/2018/hyperlinkcolor" matchingName="Big number">
+<p:sldLayout xmlns:a="http://schemas.openxmlformats.org/drawingml/2006/main" xmlns:r="http://schemas.openxmlformats.org/officeDocument/2006/relationships" xmlns:p="http://schemas.openxmlformats.org/presentationml/2006/main" matchingName="Big number">
   <p:cSld name="BIG_NUMBER">
     <p:spTree>
       <p:nvGrpSpPr>
-        <p:cNvPr id="44" name="Shape 44"/>
+        <p:cNvPr id="1" name="Shape 44"/>
         <p:cNvGrpSpPr/>
         <p:nvPr/>
       </p:nvGrpSpPr>
@@ -1188,9 +1218,11 @@
       <p:sp>
         <p:nvSpPr>
           <p:cNvPr id="45" name="Google Shape;45;p11"/>
-          <p:cNvSpPr txBox="1"/>
+          <p:cNvSpPr txBox="1">
+            <a:spLocks noGrp="1"/>
+          </p:cNvSpPr>
           <p:nvPr>
-            <p:ph hasCustomPrompt="1" type="title"/>
+            <p:ph type="title" hasCustomPrompt="1"/>
           </p:nvPr>
         </p:nvSpPr>
         <p:spPr>
@@ -1203,7 +1235,7 @@
           </a:prstGeom>
         </p:spPr>
         <p:txBody>
-          <a:bodyPr anchorCtr="0" anchor="b" bIns="91425" lIns="91425" spcFirstLastPara="1" rIns="91425" wrap="square" tIns="91425">
+          <a:bodyPr spcFirstLastPara="1" wrap="square" lIns="91425" tIns="91425" rIns="91425" bIns="91425" anchor="b" anchorCtr="0">
             <a:normAutofit/>
           </a:bodyPr>
           <a:lstStyle>
@@ -1317,9 +1349,11 @@
       <p:sp>
         <p:nvSpPr>
           <p:cNvPr id="46" name="Google Shape;46;p11"/>
-          <p:cNvSpPr txBox="1"/>
+          <p:cNvSpPr txBox="1">
+            <a:spLocks noGrp="1"/>
+          </p:cNvSpPr>
           <p:nvPr>
-            <p:ph idx="1" type="body"/>
+            <p:ph type="body" idx="1"/>
           </p:nvPr>
         </p:nvSpPr>
         <p:spPr>
@@ -1332,11 +1366,11 @@
           </a:prstGeom>
         </p:spPr>
         <p:txBody>
-          <a:bodyPr anchorCtr="0" anchor="t" bIns="91425" lIns="91425" spcFirstLastPara="1" rIns="91425" wrap="square" tIns="91425">
+          <a:bodyPr spcFirstLastPara="1" wrap="square" lIns="91425" tIns="91425" rIns="91425" bIns="91425" anchor="t" anchorCtr="0">
             <a:normAutofit/>
           </a:bodyPr>
           <a:lstStyle>
-            <a:lvl1pPr indent="-342900" lvl="0" marL="457200" algn="ctr">
+            <a:lvl1pPr marL="457200" lvl="0" indent="-342900" algn="ctr">
               <a:spcBef>
                 <a:spcPts val="0"/>
               </a:spcBef>
@@ -1347,7 +1381,7 @@
               <a:buChar char="●"/>
               <a:defRPr/>
             </a:lvl1pPr>
-            <a:lvl2pPr indent="-317500" lvl="1" marL="914400" algn="ctr">
+            <a:lvl2pPr marL="914400" lvl="1" indent="-317500" algn="ctr">
               <a:spcBef>
                 <a:spcPts val="0"/>
               </a:spcBef>
@@ -1358,7 +1392,7 @@
               <a:buChar char="○"/>
               <a:defRPr/>
             </a:lvl2pPr>
-            <a:lvl3pPr indent="-317500" lvl="2" marL="1371600" algn="ctr">
+            <a:lvl3pPr marL="1371600" lvl="2" indent="-317500" algn="ctr">
               <a:spcBef>
                 <a:spcPts val="0"/>
               </a:spcBef>
@@ -1369,7 +1403,7 @@
               <a:buChar char="■"/>
               <a:defRPr/>
             </a:lvl3pPr>
-            <a:lvl4pPr indent="-317500" lvl="3" marL="1828800" algn="ctr">
+            <a:lvl4pPr marL="1828800" lvl="3" indent="-317500" algn="ctr">
               <a:spcBef>
                 <a:spcPts val="0"/>
               </a:spcBef>
@@ -1380,7 +1414,7 @@
               <a:buChar char="●"/>
               <a:defRPr/>
             </a:lvl4pPr>
-            <a:lvl5pPr indent="-317500" lvl="4" marL="2286000" algn="ctr">
+            <a:lvl5pPr marL="2286000" lvl="4" indent="-317500" algn="ctr">
               <a:spcBef>
                 <a:spcPts val="0"/>
               </a:spcBef>
@@ -1391,7 +1425,7 @@
               <a:buChar char="○"/>
               <a:defRPr/>
             </a:lvl5pPr>
-            <a:lvl6pPr indent="-317500" lvl="5" marL="2743200" algn="ctr">
+            <a:lvl6pPr marL="2743200" lvl="5" indent="-317500" algn="ctr">
               <a:spcBef>
                 <a:spcPts val="0"/>
               </a:spcBef>
@@ -1402,7 +1436,7 @@
               <a:buChar char="■"/>
               <a:defRPr/>
             </a:lvl6pPr>
-            <a:lvl7pPr indent="-317500" lvl="6" marL="3200400" algn="ctr">
+            <a:lvl7pPr marL="3200400" lvl="6" indent="-317500" algn="ctr">
               <a:spcBef>
                 <a:spcPts val="0"/>
               </a:spcBef>
@@ -1413,7 +1447,7 @@
               <a:buChar char="●"/>
               <a:defRPr/>
             </a:lvl7pPr>
-            <a:lvl8pPr indent="-317500" lvl="7" marL="3657600" algn="ctr">
+            <a:lvl8pPr marL="3657600" lvl="7" indent="-317500" algn="ctr">
               <a:spcBef>
                 <a:spcPts val="0"/>
               </a:spcBef>
@@ -1424,7 +1458,7 @@
               <a:buChar char="○"/>
               <a:defRPr/>
             </a:lvl8pPr>
-            <a:lvl9pPr indent="-317500" lvl="8" marL="4114800" algn="ctr">
+            <a:lvl9pPr marL="4114800" lvl="8" indent="-317500" algn="ctr">
               <a:spcBef>
                 <a:spcPts val="0"/>
               </a:spcBef>
@@ -1436,15 +1470,19 @@
               <a:defRPr/>
             </a:lvl9pPr>
           </a:lstStyle>
-          <a:p/>
+          <a:p>
+            <a:endParaRPr/>
+          </a:p>
         </p:txBody>
       </p:sp>
       <p:sp>
         <p:nvSpPr>
           <p:cNvPr id="47" name="Google Shape;47;p11"/>
-          <p:cNvSpPr txBox="1"/>
+          <p:cNvSpPr txBox="1">
+            <a:spLocks noGrp="1"/>
+          </p:cNvSpPr>
           <p:nvPr>
-            <p:ph idx="12" type="sldNum"/>
+            <p:ph type="sldNum" idx="12"/>
           </p:nvPr>
         </p:nvSpPr>
         <p:spPr>
@@ -1457,7 +1495,7 @@
           </a:prstGeom>
         </p:spPr>
         <p:txBody>
-          <a:bodyPr anchorCtr="0" anchor="ctr" bIns="91425" lIns="91425" spcFirstLastPara="1" rIns="91425" wrap="square" tIns="91425">
+          <a:bodyPr spcFirstLastPara="1" wrap="square" lIns="91425" tIns="91425" rIns="91425" bIns="91425" anchor="ctr" anchorCtr="0">
             <a:normAutofit/>
           </a:bodyPr>
           <a:lstStyle>
@@ -1499,7 +1537,7 @@
             </a:lvl9pPr>
           </a:lstStyle>
           <a:p>
-            <a:pPr indent="0" lvl="0" marL="0" rtl="0" algn="r">
+            <a:pPr marL="0" lvl="0" indent="0" algn="r" rtl="0">
               <a:spcBef>
                 <a:spcPts val="0"/>
               </a:spcBef>
@@ -1525,11 +1563,11 @@
 </file>
 
 <file path=ppt/slideLayouts/slideLayout11.xml><?xml version="1.0" encoding="utf-8"?>
-<p:sldLayout xmlns:a="http://schemas.openxmlformats.org/drawingml/2006/main" xmlns:r="http://schemas.openxmlformats.org/officeDocument/2006/relationships" xmlns:mc="http://schemas.openxmlformats.org/markup-compatibility/2006" xmlns:mv="urn:schemas-microsoft-com:mac:vml" xmlns:p="http://schemas.openxmlformats.org/presentationml/2006/main" xmlns:c="http://schemas.openxmlformats.org/drawingml/2006/chart" xmlns:dgm="http://schemas.openxmlformats.org/drawingml/2006/diagram" xmlns:o="urn:schemas-microsoft-com:office:office" xmlns:v="urn:schemas-microsoft-com:vml" xmlns:pvml="urn:schemas-microsoft-com:office:powerpoint" xmlns:com="http://schemas.openxmlformats.org/drawingml/2006/compatibility" xmlns:p14="http://schemas.microsoft.com/office/powerpoint/2010/main" xmlns:p15="http://schemas.microsoft.com/office/powerpoint/2012/main" xmlns:ahyp="http://schemas.microsoft.com/office/drawing/2018/hyperlinkcolor" matchingName="Blank" type="blank">
+<p:sldLayout xmlns:a="http://schemas.openxmlformats.org/drawingml/2006/main" xmlns:r="http://schemas.openxmlformats.org/officeDocument/2006/relationships" xmlns:p="http://schemas.openxmlformats.org/presentationml/2006/main" matchingName="Blank" type="blank">
   <p:cSld name="BLANK">
     <p:spTree>
       <p:nvGrpSpPr>
-        <p:cNvPr id="48" name="Shape 48"/>
+        <p:cNvPr id="1" name="Shape 48"/>
         <p:cNvGrpSpPr/>
         <p:nvPr/>
       </p:nvGrpSpPr>
@@ -1544,9 +1582,11 @@
       <p:sp>
         <p:nvSpPr>
           <p:cNvPr id="49" name="Google Shape;49;p12"/>
-          <p:cNvSpPr txBox="1"/>
+          <p:cNvSpPr txBox="1">
+            <a:spLocks noGrp="1"/>
+          </p:cNvSpPr>
           <p:nvPr>
-            <p:ph idx="12" type="sldNum"/>
+            <p:ph type="sldNum" idx="12"/>
           </p:nvPr>
         </p:nvSpPr>
         <p:spPr>
@@ -1559,7 +1599,7 @@
           </a:prstGeom>
         </p:spPr>
         <p:txBody>
-          <a:bodyPr anchorCtr="0" anchor="ctr" bIns="91425" lIns="91425" spcFirstLastPara="1" rIns="91425" wrap="square" tIns="91425">
+          <a:bodyPr spcFirstLastPara="1" wrap="square" lIns="91425" tIns="91425" rIns="91425" bIns="91425" anchor="ctr" anchorCtr="0">
             <a:normAutofit/>
           </a:bodyPr>
           <a:lstStyle>
@@ -1601,7 +1641,7 @@
             </a:lvl9pPr>
           </a:lstStyle>
           <a:p>
-            <a:pPr indent="0" lvl="0" marL="0" rtl="0" algn="r">
+            <a:pPr marL="0" lvl="0" indent="0" algn="r" rtl="0">
               <a:spcBef>
                 <a:spcPts val="0"/>
               </a:spcBef>
@@ -1627,11 +1667,11 @@
 </file>
 
 <file path=ppt/slideLayouts/slideLayout2.xml><?xml version="1.0" encoding="utf-8"?>
-<p:sldLayout xmlns:a="http://schemas.openxmlformats.org/drawingml/2006/main" xmlns:r="http://schemas.openxmlformats.org/officeDocument/2006/relationships" xmlns:mc="http://schemas.openxmlformats.org/markup-compatibility/2006" xmlns:mv="urn:schemas-microsoft-com:mac:vml" xmlns:p="http://schemas.openxmlformats.org/presentationml/2006/main" xmlns:c="http://schemas.openxmlformats.org/drawingml/2006/chart" xmlns:dgm="http://schemas.openxmlformats.org/drawingml/2006/diagram" xmlns:o="urn:schemas-microsoft-com:office:office" xmlns:v="urn:schemas-microsoft-com:vml" xmlns:pvml="urn:schemas-microsoft-com:office:powerpoint" xmlns:com="http://schemas.openxmlformats.org/drawingml/2006/compatibility" xmlns:p14="http://schemas.microsoft.com/office/powerpoint/2010/main" xmlns:p15="http://schemas.microsoft.com/office/powerpoint/2012/main" xmlns:ahyp="http://schemas.microsoft.com/office/drawing/2018/hyperlinkcolor" matchingName="Section header" type="secHead">
+<p:sldLayout xmlns:a="http://schemas.openxmlformats.org/drawingml/2006/main" xmlns:r="http://schemas.openxmlformats.org/officeDocument/2006/relationships" xmlns:p="http://schemas.openxmlformats.org/presentationml/2006/main" matchingName="Section header" type="secHead">
   <p:cSld name="SECTION_HEADER">
     <p:spTree>
       <p:nvGrpSpPr>
-        <p:cNvPr id="13" name="Shape 13"/>
+        <p:cNvPr id="1" name="Shape 13"/>
         <p:cNvGrpSpPr/>
         <p:nvPr/>
       </p:nvGrpSpPr>
@@ -1646,7 +1686,9 @@
       <p:sp>
         <p:nvSpPr>
           <p:cNvPr id="14" name="Google Shape;14;p3"/>
-          <p:cNvSpPr txBox="1"/>
+          <p:cNvSpPr txBox="1">
+            <a:spLocks noGrp="1"/>
+          </p:cNvSpPr>
           <p:nvPr>
             <p:ph type="title"/>
           </p:nvPr>
@@ -1661,7 +1703,7 @@
           </a:prstGeom>
         </p:spPr>
         <p:txBody>
-          <a:bodyPr anchorCtr="0" anchor="ctr" bIns="91425" lIns="91425" spcFirstLastPara="1" rIns="91425" wrap="square" tIns="91425">
+          <a:bodyPr spcFirstLastPara="1" wrap="square" lIns="91425" tIns="91425" rIns="91425" bIns="91425" anchor="ctr" anchorCtr="0">
             <a:normAutofit/>
           </a:bodyPr>
           <a:lstStyle>
@@ -1765,15 +1807,19 @@
               <a:defRPr sz="3600"/>
             </a:lvl9pPr>
           </a:lstStyle>
-          <a:p/>
+          <a:p>
+            <a:endParaRPr/>
+          </a:p>
         </p:txBody>
       </p:sp>
       <p:sp>
         <p:nvSpPr>
           <p:cNvPr id="15" name="Google Shape;15;p3"/>
-          <p:cNvSpPr txBox="1"/>
+          <p:cNvSpPr txBox="1">
+            <a:spLocks noGrp="1"/>
+          </p:cNvSpPr>
           <p:nvPr>
-            <p:ph idx="12" type="sldNum"/>
+            <p:ph type="sldNum" idx="12"/>
           </p:nvPr>
         </p:nvSpPr>
         <p:spPr>
@@ -1786,7 +1832,7 @@
           </a:prstGeom>
         </p:spPr>
         <p:txBody>
-          <a:bodyPr anchorCtr="0" anchor="ctr" bIns="91425" lIns="91425" spcFirstLastPara="1" rIns="91425" wrap="square" tIns="91425">
+          <a:bodyPr spcFirstLastPara="1" wrap="square" lIns="91425" tIns="91425" rIns="91425" bIns="91425" anchor="ctr" anchorCtr="0">
             <a:normAutofit/>
           </a:bodyPr>
           <a:lstStyle>
@@ -1828,7 +1874,7 @@
             </a:lvl9pPr>
           </a:lstStyle>
           <a:p>
-            <a:pPr indent="0" lvl="0" marL="0" rtl="0" algn="r">
+            <a:pPr marL="0" lvl="0" indent="0" algn="r" rtl="0">
               <a:spcBef>
                 <a:spcPts val="0"/>
               </a:spcBef>
@@ -1854,11 +1900,11 @@
 </file>
 
 <file path=ppt/slideLayouts/slideLayout3.xml><?xml version="1.0" encoding="utf-8"?>
-<p:sldLayout xmlns:a="http://schemas.openxmlformats.org/drawingml/2006/main" xmlns:r="http://schemas.openxmlformats.org/officeDocument/2006/relationships" xmlns:mc="http://schemas.openxmlformats.org/markup-compatibility/2006" xmlns:mv="urn:schemas-microsoft-com:mac:vml" xmlns:p="http://schemas.openxmlformats.org/presentationml/2006/main" xmlns:c="http://schemas.openxmlformats.org/drawingml/2006/chart" xmlns:dgm="http://schemas.openxmlformats.org/drawingml/2006/diagram" xmlns:o="urn:schemas-microsoft-com:office:office" xmlns:v="urn:schemas-microsoft-com:vml" xmlns:pvml="urn:schemas-microsoft-com:office:powerpoint" xmlns:com="http://schemas.openxmlformats.org/drawingml/2006/compatibility" xmlns:p14="http://schemas.microsoft.com/office/powerpoint/2010/main" xmlns:p15="http://schemas.microsoft.com/office/powerpoint/2012/main" xmlns:ahyp="http://schemas.microsoft.com/office/drawing/2018/hyperlinkcolor" matchingName="Title and body" type="tx">
+<p:sldLayout xmlns:a="http://schemas.openxmlformats.org/drawingml/2006/main" xmlns:r="http://schemas.openxmlformats.org/officeDocument/2006/relationships" xmlns:p="http://schemas.openxmlformats.org/presentationml/2006/main" matchingName="Title and body" type="tx">
   <p:cSld name="TITLE_AND_BODY">
     <p:spTree>
       <p:nvGrpSpPr>
-        <p:cNvPr id="16" name="Shape 16"/>
+        <p:cNvPr id="1" name="Shape 16"/>
         <p:cNvGrpSpPr/>
         <p:nvPr/>
       </p:nvGrpSpPr>
@@ -1873,7 +1919,9 @@
       <p:sp>
         <p:nvSpPr>
           <p:cNvPr id="17" name="Google Shape;17;p4"/>
-          <p:cNvSpPr txBox="1"/>
+          <p:cNvSpPr txBox="1">
+            <a:spLocks noGrp="1"/>
+          </p:cNvSpPr>
           <p:nvPr>
             <p:ph type="title"/>
           </p:nvPr>
@@ -1888,7 +1936,7 @@
           </a:prstGeom>
         </p:spPr>
         <p:txBody>
-          <a:bodyPr anchorCtr="0" anchor="t" bIns="91425" lIns="91425" spcFirstLastPara="1" rIns="91425" wrap="square" tIns="91425">
+          <a:bodyPr spcFirstLastPara="1" wrap="square" lIns="91425" tIns="91425" rIns="91425" bIns="91425" anchor="t" anchorCtr="0">
             <a:normAutofit/>
           </a:bodyPr>
           <a:lstStyle>
@@ -1992,15 +2040,19 @@
               <a:defRPr/>
             </a:lvl9pPr>
           </a:lstStyle>
-          <a:p/>
+          <a:p>
+            <a:endParaRPr/>
+          </a:p>
         </p:txBody>
       </p:sp>
       <p:sp>
         <p:nvSpPr>
           <p:cNvPr id="18" name="Google Shape;18;p4"/>
-          <p:cNvSpPr txBox="1"/>
+          <p:cNvSpPr txBox="1">
+            <a:spLocks noGrp="1"/>
+          </p:cNvSpPr>
           <p:nvPr>
-            <p:ph idx="1" type="body"/>
+            <p:ph type="body" idx="1"/>
           </p:nvPr>
         </p:nvSpPr>
         <p:spPr>
@@ -2013,11 +2065,11 @@
           </a:prstGeom>
         </p:spPr>
         <p:txBody>
-          <a:bodyPr anchorCtr="0" anchor="t" bIns="91425" lIns="91425" spcFirstLastPara="1" rIns="91425" wrap="square" tIns="91425">
+          <a:bodyPr spcFirstLastPara="1" wrap="square" lIns="91425" tIns="91425" rIns="91425" bIns="91425" anchor="t" anchorCtr="0">
             <a:normAutofit/>
           </a:bodyPr>
           <a:lstStyle>
-            <a:lvl1pPr indent="-342900" lvl="0" marL="457200">
+            <a:lvl1pPr marL="457200" lvl="0" indent="-342900">
               <a:spcBef>
                 <a:spcPts val="0"/>
               </a:spcBef>
@@ -2028,7 +2080,7 @@
               <a:buChar char="●"/>
               <a:defRPr/>
             </a:lvl1pPr>
-            <a:lvl2pPr indent="-317500" lvl="1" marL="914400">
+            <a:lvl2pPr marL="914400" lvl="1" indent="-317500">
               <a:spcBef>
                 <a:spcPts val="0"/>
               </a:spcBef>
@@ -2039,7 +2091,7 @@
               <a:buChar char="○"/>
               <a:defRPr/>
             </a:lvl2pPr>
-            <a:lvl3pPr indent="-317500" lvl="2" marL="1371600">
+            <a:lvl3pPr marL="1371600" lvl="2" indent="-317500">
               <a:spcBef>
                 <a:spcPts val="0"/>
               </a:spcBef>
@@ -2050,7 +2102,7 @@
               <a:buChar char="■"/>
               <a:defRPr/>
             </a:lvl3pPr>
-            <a:lvl4pPr indent="-317500" lvl="3" marL="1828800">
+            <a:lvl4pPr marL="1828800" lvl="3" indent="-317500">
               <a:spcBef>
                 <a:spcPts val="0"/>
               </a:spcBef>
@@ -2061,7 +2113,7 @@
               <a:buChar char="●"/>
               <a:defRPr/>
             </a:lvl4pPr>
-            <a:lvl5pPr indent="-317500" lvl="4" marL="2286000">
+            <a:lvl5pPr marL="2286000" lvl="4" indent="-317500">
               <a:spcBef>
                 <a:spcPts val="0"/>
               </a:spcBef>
@@ -2072,7 +2124,7 @@
               <a:buChar char="○"/>
               <a:defRPr/>
             </a:lvl5pPr>
-            <a:lvl6pPr indent="-317500" lvl="5" marL="2743200">
+            <a:lvl6pPr marL="2743200" lvl="5" indent="-317500">
               <a:spcBef>
                 <a:spcPts val="0"/>
               </a:spcBef>
@@ -2083,7 +2135,7 @@
               <a:buChar char="■"/>
               <a:defRPr/>
             </a:lvl6pPr>
-            <a:lvl7pPr indent="-317500" lvl="6" marL="3200400">
+            <a:lvl7pPr marL="3200400" lvl="6" indent="-317500">
               <a:spcBef>
                 <a:spcPts val="0"/>
               </a:spcBef>
@@ -2094,7 +2146,7 @@
               <a:buChar char="●"/>
               <a:defRPr/>
             </a:lvl7pPr>
-            <a:lvl8pPr indent="-317500" lvl="7" marL="3657600">
+            <a:lvl8pPr marL="3657600" lvl="7" indent="-317500">
               <a:spcBef>
                 <a:spcPts val="0"/>
               </a:spcBef>
@@ -2105,7 +2157,7 @@
               <a:buChar char="○"/>
               <a:defRPr/>
             </a:lvl8pPr>
-            <a:lvl9pPr indent="-317500" lvl="8" marL="4114800">
+            <a:lvl9pPr marL="4114800" lvl="8" indent="-317500">
               <a:spcBef>
                 <a:spcPts val="0"/>
               </a:spcBef>
@@ -2117,15 +2169,19 @@
               <a:defRPr/>
             </a:lvl9pPr>
           </a:lstStyle>
-          <a:p/>
+          <a:p>
+            <a:endParaRPr/>
+          </a:p>
         </p:txBody>
       </p:sp>
       <p:sp>
         <p:nvSpPr>
           <p:cNvPr id="19" name="Google Shape;19;p4"/>
-          <p:cNvSpPr txBox="1"/>
+          <p:cNvSpPr txBox="1">
+            <a:spLocks noGrp="1"/>
+          </p:cNvSpPr>
           <p:nvPr>
-            <p:ph idx="12" type="sldNum"/>
+            <p:ph type="sldNum" idx="12"/>
           </p:nvPr>
         </p:nvSpPr>
         <p:spPr>
@@ -2138,7 +2194,7 @@
           </a:prstGeom>
         </p:spPr>
         <p:txBody>
-          <a:bodyPr anchorCtr="0" anchor="ctr" bIns="91425" lIns="91425" spcFirstLastPara="1" rIns="91425" wrap="square" tIns="91425">
+          <a:bodyPr spcFirstLastPara="1" wrap="square" lIns="91425" tIns="91425" rIns="91425" bIns="91425" anchor="ctr" anchorCtr="0">
             <a:normAutofit/>
           </a:bodyPr>
           <a:lstStyle>
@@ -2180,7 +2236,7 @@
             </a:lvl9pPr>
           </a:lstStyle>
           <a:p>
-            <a:pPr indent="0" lvl="0" marL="0" rtl="0" algn="r">
+            <a:pPr marL="0" lvl="0" indent="0" algn="r" rtl="0">
               <a:spcBef>
                 <a:spcPts val="0"/>
               </a:spcBef>
@@ -2206,11 +2262,11 @@
 </file>
 
 <file path=ppt/slideLayouts/slideLayout4.xml><?xml version="1.0" encoding="utf-8"?>
-<p:sldLayout xmlns:a="http://schemas.openxmlformats.org/drawingml/2006/main" xmlns:r="http://schemas.openxmlformats.org/officeDocument/2006/relationships" xmlns:mc="http://schemas.openxmlformats.org/markup-compatibility/2006" xmlns:mv="urn:schemas-microsoft-com:mac:vml" xmlns:p="http://schemas.openxmlformats.org/presentationml/2006/main" xmlns:c="http://schemas.openxmlformats.org/drawingml/2006/chart" xmlns:dgm="http://schemas.openxmlformats.org/drawingml/2006/diagram" xmlns:o="urn:schemas-microsoft-com:office:office" xmlns:v="urn:schemas-microsoft-com:vml" xmlns:pvml="urn:schemas-microsoft-com:office:powerpoint" xmlns:com="http://schemas.openxmlformats.org/drawingml/2006/compatibility" xmlns:p14="http://schemas.microsoft.com/office/powerpoint/2010/main" xmlns:p15="http://schemas.microsoft.com/office/powerpoint/2012/main" xmlns:ahyp="http://schemas.microsoft.com/office/drawing/2018/hyperlinkcolor" matchingName="Title and two columns" type="twoColTx">
+<p:sldLayout xmlns:a="http://schemas.openxmlformats.org/drawingml/2006/main" xmlns:r="http://schemas.openxmlformats.org/officeDocument/2006/relationships" xmlns:p="http://schemas.openxmlformats.org/presentationml/2006/main" matchingName="Title and two columns" type="twoColTx">
   <p:cSld name="TITLE_AND_TWO_COLUMNS">
     <p:spTree>
       <p:nvGrpSpPr>
-        <p:cNvPr id="20" name="Shape 20"/>
+        <p:cNvPr id="1" name="Shape 20"/>
         <p:cNvGrpSpPr/>
         <p:nvPr/>
       </p:nvGrpSpPr>
@@ -2225,7 +2281,9 @@
       <p:sp>
         <p:nvSpPr>
           <p:cNvPr id="21" name="Google Shape;21;p5"/>
-          <p:cNvSpPr txBox="1"/>
+          <p:cNvSpPr txBox="1">
+            <a:spLocks noGrp="1"/>
+          </p:cNvSpPr>
           <p:nvPr>
             <p:ph type="title"/>
           </p:nvPr>
@@ -2240,7 +2298,7 @@
           </a:prstGeom>
         </p:spPr>
         <p:txBody>
-          <a:bodyPr anchorCtr="0" anchor="t" bIns="91425" lIns="91425" spcFirstLastPara="1" rIns="91425" wrap="square" tIns="91425">
+          <a:bodyPr spcFirstLastPara="1" wrap="square" lIns="91425" tIns="91425" rIns="91425" bIns="91425" anchor="t" anchorCtr="0">
             <a:normAutofit/>
           </a:bodyPr>
           <a:lstStyle>
@@ -2344,15 +2402,19 @@
               <a:defRPr/>
             </a:lvl9pPr>
           </a:lstStyle>
-          <a:p/>
+          <a:p>
+            <a:endParaRPr/>
+          </a:p>
         </p:txBody>
       </p:sp>
       <p:sp>
         <p:nvSpPr>
           <p:cNvPr id="22" name="Google Shape;22;p5"/>
-          <p:cNvSpPr txBox="1"/>
+          <p:cNvSpPr txBox="1">
+            <a:spLocks noGrp="1"/>
+          </p:cNvSpPr>
           <p:nvPr>
-            <p:ph idx="1" type="body"/>
+            <p:ph type="body" idx="1"/>
           </p:nvPr>
         </p:nvSpPr>
         <p:spPr>
@@ -2365,11 +2427,11 @@
           </a:prstGeom>
         </p:spPr>
         <p:txBody>
-          <a:bodyPr anchorCtr="0" anchor="t" bIns="91425" lIns="91425" spcFirstLastPara="1" rIns="91425" wrap="square" tIns="91425">
+          <a:bodyPr spcFirstLastPara="1" wrap="square" lIns="91425" tIns="91425" rIns="91425" bIns="91425" anchor="t" anchorCtr="0">
             <a:normAutofit/>
           </a:bodyPr>
           <a:lstStyle>
-            <a:lvl1pPr indent="-317500" lvl="0" marL="457200">
+            <a:lvl1pPr marL="457200" lvl="0" indent="-317500">
               <a:spcBef>
                 <a:spcPts val="0"/>
               </a:spcBef>
@@ -2380,7 +2442,7 @@
               <a:buChar char="●"/>
               <a:defRPr sz="1400"/>
             </a:lvl1pPr>
-            <a:lvl2pPr indent="-304800" lvl="1" marL="914400">
+            <a:lvl2pPr marL="914400" lvl="1" indent="-304800">
               <a:spcBef>
                 <a:spcPts val="0"/>
               </a:spcBef>
@@ -2391,7 +2453,7 @@
               <a:buChar char="○"/>
               <a:defRPr sz="1200"/>
             </a:lvl2pPr>
-            <a:lvl3pPr indent="-304800" lvl="2" marL="1371600">
+            <a:lvl3pPr marL="1371600" lvl="2" indent="-304800">
               <a:spcBef>
                 <a:spcPts val="0"/>
               </a:spcBef>
@@ -2402,7 +2464,7 @@
               <a:buChar char="■"/>
               <a:defRPr sz="1200"/>
             </a:lvl3pPr>
-            <a:lvl4pPr indent="-304800" lvl="3" marL="1828800">
+            <a:lvl4pPr marL="1828800" lvl="3" indent="-304800">
               <a:spcBef>
                 <a:spcPts val="0"/>
               </a:spcBef>
@@ -2413,7 +2475,7 @@
               <a:buChar char="●"/>
               <a:defRPr sz="1200"/>
             </a:lvl4pPr>
-            <a:lvl5pPr indent="-304800" lvl="4" marL="2286000">
+            <a:lvl5pPr marL="2286000" lvl="4" indent="-304800">
               <a:spcBef>
                 <a:spcPts val="0"/>
               </a:spcBef>
@@ -2424,7 +2486,7 @@
               <a:buChar char="○"/>
               <a:defRPr sz="1200"/>
             </a:lvl5pPr>
-            <a:lvl6pPr indent="-304800" lvl="5" marL="2743200">
+            <a:lvl6pPr marL="2743200" lvl="5" indent="-304800">
               <a:spcBef>
                 <a:spcPts val="0"/>
               </a:spcBef>
@@ -2435,7 +2497,7 @@
               <a:buChar char="■"/>
               <a:defRPr sz="1200"/>
             </a:lvl6pPr>
-            <a:lvl7pPr indent="-304800" lvl="6" marL="3200400">
+            <a:lvl7pPr marL="3200400" lvl="6" indent="-304800">
               <a:spcBef>
                 <a:spcPts val="0"/>
               </a:spcBef>
@@ -2446,7 +2508,7 @@
               <a:buChar char="●"/>
               <a:defRPr sz="1200"/>
             </a:lvl7pPr>
-            <a:lvl8pPr indent="-304800" lvl="7" marL="3657600">
+            <a:lvl8pPr marL="3657600" lvl="7" indent="-304800">
               <a:spcBef>
                 <a:spcPts val="0"/>
               </a:spcBef>
@@ -2457,7 +2519,7 @@
               <a:buChar char="○"/>
               <a:defRPr sz="1200"/>
             </a:lvl8pPr>
-            <a:lvl9pPr indent="-304800" lvl="8" marL="4114800">
+            <a:lvl9pPr marL="4114800" lvl="8" indent="-304800">
               <a:spcBef>
                 <a:spcPts val="0"/>
               </a:spcBef>
@@ -2469,15 +2531,19 @@
               <a:defRPr sz="1200"/>
             </a:lvl9pPr>
           </a:lstStyle>
-          <a:p/>
+          <a:p>
+            <a:endParaRPr/>
+          </a:p>
         </p:txBody>
       </p:sp>
       <p:sp>
         <p:nvSpPr>
           <p:cNvPr id="23" name="Google Shape;23;p5"/>
-          <p:cNvSpPr txBox="1"/>
+          <p:cNvSpPr txBox="1">
+            <a:spLocks noGrp="1"/>
+          </p:cNvSpPr>
           <p:nvPr>
-            <p:ph idx="2" type="body"/>
+            <p:ph type="body" idx="2"/>
           </p:nvPr>
         </p:nvSpPr>
         <p:spPr>
@@ -2490,11 +2556,11 @@
           </a:prstGeom>
         </p:spPr>
         <p:txBody>
-          <a:bodyPr anchorCtr="0" anchor="t" bIns="91425" lIns="91425" spcFirstLastPara="1" rIns="91425" wrap="square" tIns="91425">
+          <a:bodyPr spcFirstLastPara="1" wrap="square" lIns="91425" tIns="91425" rIns="91425" bIns="91425" anchor="t" anchorCtr="0">
             <a:normAutofit/>
           </a:bodyPr>
           <a:lstStyle>
-            <a:lvl1pPr indent="-317500" lvl="0" marL="457200">
+            <a:lvl1pPr marL="457200" lvl="0" indent="-317500">
               <a:spcBef>
                 <a:spcPts val="0"/>
               </a:spcBef>
@@ -2505,7 +2571,7 @@
               <a:buChar char="●"/>
               <a:defRPr sz="1400"/>
             </a:lvl1pPr>
-            <a:lvl2pPr indent="-304800" lvl="1" marL="914400">
+            <a:lvl2pPr marL="914400" lvl="1" indent="-304800">
               <a:spcBef>
                 <a:spcPts val="0"/>
               </a:spcBef>
@@ -2516,7 +2582,7 @@
               <a:buChar char="○"/>
               <a:defRPr sz="1200"/>
             </a:lvl2pPr>
-            <a:lvl3pPr indent="-304800" lvl="2" marL="1371600">
+            <a:lvl3pPr marL="1371600" lvl="2" indent="-304800">
               <a:spcBef>
                 <a:spcPts val="0"/>
               </a:spcBef>
@@ -2527,7 +2593,7 @@
               <a:buChar char="■"/>
               <a:defRPr sz="1200"/>
             </a:lvl3pPr>
-            <a:lvl4pPr indent="-304800" lvl="3" marL="1828800">
+            <a:lvl4pPr marL="1828800" lvl="3" indent="-304800">
               <a:spcBef>
                 <a:spcPts val="0"/>
               </a:spcBef>
@@ -2538,7 +2604,7 @@
               <a:buChar char="●"/>
               <a:defRPr sz="1200"/>
             </a:lvl4pPr>
-            <a:lvl5pPr indent="-304800" lvl="4" marL="2286000">
+            <a:lvl5pPr marL="2286000" lvl="4" indent="-304800">
               <a:spcBef>
                 <a:spcPts val="0"/>
               </a:spcBef>
@@ -2549,7 +2615,7 @@
               <a:buChar char="○"/>
               <a:defRPr sz="1200"/>
             </a:lvl5pPr>
-            <a:lvl6pPr indent="-304800" lvl="5" marL="2743200">
+            <a:lvl6pPr marL="2743200" lvl="5" indent="-304800">
               <a:spcBef>
                 <a:spcPts val="0"/>
               </a:spcBef>
@@ -2560,7 +2626,7 @@
               <a:buChar char="■"/>
               <a:defRPr sz="1200"/>
             </a:lvl6pPr>
-            <a:lvl7pPr indent="-304800" lvl="6" marL="3200400">
+            <a:lvl7pPr marL="3200400" lvl="6" indent="-304800">
               <a:spcBef>
                 <a:spcPts val="0"/>
               </a:spcBef>
@@ -2571,7 +2637,7 @@
               <a:buChar char="●"/>
               <a:defRPr sz="1200"/>
             </a:lvl7pPr>
-            <a:lvl8pPr indent="-304800" lvl="7" marL="3657600">
+            <a:lvl8pPr marL="3657600" lvl="7" indent="-304800">
               <a:spcBef>
                 <a:spcPts val="0"/>
               </a:spcBef>
@@ -2582,7 +2648,7 @@
               <a:buChar char="○"/>
               <a:defRPr sz="1200"/>
             </a:lvl8pPr>
-            <a:lvl9pPr indent="-304800" lvl="8" marL="4114800">
+            <a:lvl9pPr marL="4114800" lvl="8" indent="-304800">
               <a:spcBef>
                 <a:spcPts val="0"/>
               </a:spcBef>
@@ -2594,15 +2660,19 @@
               <a:defRPr sz="1200"/>
             </a:lvl9pPr>
           </a:lstStyle>
-          <a:p/>
+          <a:p>
+            <a:endParaRPr/>
+          </a:p>
         </p:txBody>
       </p:sp>
       <p:sp>
         <p:nvSpPr>
           <p:cNvPr id="24" name="Google Shape;24;p5"/>
-          <p:cNvSpPr txBox="1"/>
+          <p:cNvSpPr txBox="1">
+            <a:spLocks noGrp="1"/>
+          </p:cNvSpPr>
           <p:nvPr>
-            <p:ph idx="12" type="sldNum"/>
+            <p:ph type="sldNum" idx="12"/>
           </p:nvPr>
         </p:nvSpPr>
         <p:spPr>
@@ -2615,7 +2685,7 @@
           </a:prstGeom>
         </p:spPr>
         <p:txBody>
-          <a:bodyPr anchorCtr="0" anchor="ctr" bIns="91425" lIns="91425" spcFirstLastPara="1" rIns="91425" wrap="square" tIns="91425">
+          <a:bodyPr spcFirstLastPara="1" wrap="square" lIns="91425" tIns="91425" rIns="91425" bIns="91425" anchor="ctr" anchorCtr="0">
             <a:normAutofit/>
           </a:bodyPr>
           <a:lstStyle>
@@ -2657,7 +2727,7 @@
             </a:lvl9pPr>
           </a:lstStyle>
           <a:p>
-            <a:pPr indent="0" lvl="0" marL="0" rtl="0" algn="r">
+            <a:pPr marL="0" lvl="0" indent="0" algn="r" rtl="0">
               <a:spcBef>
                 <a:spcPts val="0"/>
               </a:spcBef>
@@ -2683,11 +2753,11 @@
 </file>
 
 <file path=ppt/slideLayouts/slideLayout5.xml><?xml version="1.0" encoding="utf-8"?>
-<p:sldLayout xmlns:a="http://schemas.openxmlformats.org/drawingml/2006/main" xmlns:r="http://schemas.openxmlformats.org/officeDocument/2006/relationships" xmlns:mc="http://schemas.openxmlformats.org/markup-compatibility/2006" xmlns:mv="urn:schemas-microsoft-com:mac:vml" xmlns:p="http://schemas.openxmlformats.org/presentationml/2006/main" xmlns:c="http://schemas.openxmlformats.org/drawingml/2006/chart" xmlns:dgm="http://schemas.openxmlformats.org/drawingml/2006/diagram" xmlns:o="urn:schemas-microsoft-com:office:office" xmlns:v="urn:schemas-microsoft-com:vml" xmlns:pvml="urn:schemas-microsoft-com:office:powerpoint" xmlns:com="http://schemas.openxmlformats.org/drawingml/2006/compatibility" xmlns:p14="http://schemas.microsoft.com/office/powerpoint/2010/main" xmlns:p15="http://schemas.microsoft.com/office/powerpoint/2012/main" xmlns:ahyp="http://schemas.microsoft.com/office/drawing/2018/hyperlinkcolor" matchingName="Title only" type="titleOnly">
+<p:sldLayout xmlns:a="http://schemas.openxmlformats.org/drawingml/2006/main" xmlns:r="http://schemas.openxmlformats.org/officeDocument/2006/relationships" xmlns:p="http://schemas.openxmlformats.org/presentationml/2006/main" matchingName="Title only" type="titleOnly">
   <p:cSld name="TITLE_ONLY">
     <p:spTree>
       <p:nvGrpSpPr>
-        <p:cNvPr id="25" name="Shape 25"/>
+        <p:cNvPr id="1" name="Shape 25"/>
         <p:cNvGrpSpPr/>
         <p:nvPr/>
       </p:nvGrpSpPr>
@@ -2702,7 +2772,9 @@
       <p:sp>
         <p:nvSpPr>
           <p:cNvPr id="26" name="Google Shape;26;p6"/>
-          <p:cNvSpPr txBox="1"/>
+          <p:cNvSpPr txBox="1">
+            <a:spLocks noGrp="1"/>
+          </p:cNvSpPr>
           <p:nvPr>
             <p:ph type="title"/>
           </p:nvPr>
@@ -2717,7 +2789,7 @@
           </a:prstGeom>
         </p:spPr>
         <p:txBody>
-          <a:bodyPr anchorCtr="0" anchor="t" bIns="91425" lIns="91425" spcFirstLastPara="1" rIns="91425" wrap="square" tIns="91425">
+          <a:bodyPr spcFirstLastPara="1" wrap="square" lIns="91425" tIns="91425" rIns="91425" bIns="91425" anchor="t" anchorCtr="0">
             <a:normAutofit/>
           </a:bodyPr>
           <a:lstStyle>
@@ -2821,15 +2893,19 @@
               <a:defRPr/>
             </a:lvl9pPr>
           </a:lstStyle>
-          <a:p/>
+          <a:p>
+            <a:endParaRPr/>
+          </a:p>
         </p:txBody>
       </p:sp>
       <p:sp>
         <p:nvSpPr>
           <p:cNvPr id="27" name="Google Shape;27;p6"/>
-          <p:cNvSpPr txBox="1"/>
+          <p:cNvSpPr txBox="1">
+            <a:spLocks noGrp="1"/>
+          </p:cNvSpPr>
           <p:nvPr>
-            <p:ph idx="12" type="sldNum"/>
+            <p:ph type="sldNum" idx="12"/>
           </p:nvPr>
         </p:nvSpPr>
         <p:spPr>
@@ -2842,7 +2918,7 @@
           </a:prstGeom>
         </p:spPr>
         <p:txBody>
-          <a:bodyPr anchorCtr="0" anchor="ctr" bIns="91425" lIns="91425" spcFirstLastPara="1" rIns="91425" wrap="square" tIns="91425">
+          <a:bodyPr spcFirstLastPara="1" wrap="square" lIns="91425" tIns="91425" rIns="91425" bIns="91425" anchor="ctr" anchorCtr="0">
             <a:normAutofit/>
           </a:bodyPr>
           <a:lstStyle>
@@ -2884,7 +2960,7 @@
             </a:lvl9pPr>
           </a:lstStyle>
           <a:p>
-            <a:pPr indent="0" lvl="0" marL="0" rtl="0" algn="r">
+            <a:pPr marL="0" lvl="0" indent="0" algn="r" rtl="0">
               <a:spcBef>
                 <a:spcPts val="0"/>
               </a:spcBef>
@@ -2910,11 +2986,11 @@
 </file>
 
 <file path=ppt/slideLayouts/slideLayout6.xml><?xml version="1.0" encoding="utf-8"?>
-<p:sldLayout xmlns:a="http://schemas.openxmlformats.org/drawingml/2006/main" xmlns:r="http://schemas.openxmlformats.org/officeDocument/2006/relationships" xmlns:mc="http://schemas.openxmlformats.org/markup-compatibility/2006" xmlns:mv="urn:schemas-microsoft-com:mac:vml" xmlns:p="http://schemas.openxmlformats.org/presentationml/2006/main" xmlns:c="http://schemas.openxmlformats.org/drawingml/2006/chart" xmlns:dgm="http://schemas.openxmlformats.org/drawingml/2006/diagram" xmlns:o="urn:schemas-microsoft-com:office:office" xmlns:v="urn:schemas-microsoft-com:vml" xmlns:pvml="urn:schemas-microsoft-com:office:powerpoint" xmlns:com="http://schemas.openxmlformats.org/drawingml/2006/compatibility" xmlns:p14="http://schemas.microsoft.com/office/powerpoint/2010/main" xmlns:p15="http://schemas.microsoft.com/office/powerpoint/2012/main" xmlns:ahyp="http://schemas.microsoft.com/office/drawing/2018/hyperlinkcolor" matchingName="One column text">
+<p:sldLayout xmlns:a="http://schemas.openxmlformats.org/drawingml/2006/main" xmlns:r="http://schemas.openxmlformats.org/officeDocument/2006/relationships" xmlns:p="http://schemas.openxmlformats.org/presentationml/2006/main" matchingName="One column text">
   <p:cSld name="ONE_COLUMN_TEXT">
     <p:spTree>
       <p:nvGrpSpPr>
-        <p:cNvPr id="28" name="Shape 28"/>
+        <p:cNvPr id="1" name="Shape 28"/>
         <p:cNvGrpSpPr/>
         <p:nvPr/>
       </p:nvGrpSpPr>
@@ -2929,7 +3005,9 @@
       <p:sp>
         <p:nvSpPr>
           <p:cNvPr id="29" name="Google Shape;29;p7"/>
-          <p:cNvSpPr txBox="1"/>
+          <p:cNvSpPr txBox="1">
+            <a:spLocks noGrp="1"/>
+          </p:cNvSpPr>
           <p:nvPr>
             <p:ph type="title"/>
           </p:nvPr>
@@ -2944,7 +3022,7 @@
           </a:prstGeom>
         </p:spPr>
         <p:txBody>
-          <a:bodyPr anchorCtr="0" anchor="b" bIns="91425" lIns="91425" spcFirstLastPara="1" rIns="91425" wrap="square" tIns="91425">
+          <a:bodyPr spcFirstLastPara="1" wrap="square" lIns="91425" tIns="91425" rIns="91425" bIns="91425" anchor="b" anchorCtr="0">
             <a:normAutofit/>
           </a:bodyPr>
           <a:lstStyle>
@@ -3048,15 +3126,19 @@
               <a:defRPr sz="2400"/>
             </a:lvl9pPr>
           </a:lstStyle>
-          <a:p/>
+          <a:p>
+            <a:endParaRPr/>
+          </a:p>
         </p:txBody>
       </p:sp>
       <p:sp>
         <p:nvSpPr>
           <p:cNvPr id="30" name="Google Shape;30;p7"/>
-          <p:cNvSpPr txBox="1"/>
+          <p:cNvSpPr txBox="1">
+            <a:spLocks noGrp="1"/>
+          </p:cNvSpPr>
           <p:nvPr>
-            <p:ph idx="1" type="body"/>
+            <p:ph type="body" idx="1"/>
           </p:nvPr>
         </p:nvSpPr>
         <p:spPr>
@@ -3069,11 +3151,11 @@
           </a:prstGeom>
         </p:spPr>
         <p:txBody>
-          <a:bodyPr anchorCtr="0" anchor="t" bIns="91425" lIns="91425" spcFirstLastPara="1" rIns="91425" wrap="square" tIns="91425">
+          <a:bodyPr spcFirstLastPara="1" wrap="square" lIns="91425" tIns="91425" rIns="91425" bIns="91425" anchor="t" anchorCtr="0">
             <a:normAutofit/>
           </a:bodyPr>
           <a:lstStyle>
-            <a:lvl1pPr indent="-304800" lvl="0" marL="457200">
+            <a:lvl1pPr marL="457200" lvl="0" indent="-304800">
               <a:spcBef>
                 <a:spcPts val="0"/>
               </a:spcBef>
@@ -3084,7 +3166,7 @@
               <a:buChar char="●"/>
               <a:defRPr sz="1200"/>
             </a:lvl1pPr>
-            <a:lvl2pPr indent="-304800" lvl="1" marL="914400">
+            <a:lvl2pPr marL="914400" lvl="1" indent="-304800">
               <a:spcBef>
                 <a:spcPts val="0"/>
               </a:spcBef>
@@ -3095,7 +3177,7 @@
               <a:buChar char="○"/>
               <a:defRPr sz="1200"/>
             </a:lvl2pPr>
-            <a:lvl3pPr indent="-304800" lvl="2" marL="1371600">
+            <a:lvl3pPr marL="1371600" lvl="2" indent="-304800">
               <a:spcBef>
                 <a:spcPts val="0"/>
               </a:spcBef>
@@ -3106,7 +3188,7 @@
               <a:buChar char="■"/>
               <a:defRPr sz="1200"/>
             </a:lvl3pPr>
-            <a:lvl4pPr indent="-304800" lvl="3" marL="1828800">
+            <a:lvl4pPr marL="1828800" lvl="3" indent="-304800">
               <a:spcBef>
                 <a:spcPts val="0"/>
               </a:spcBef>
@@ -3117,7 +3199,7 @@
               <a:buChar char="●"/>
               <a:defRPr sz="1200"/>
             </a:lvl4pPr>
-            <a:lvl5pPr indent="-304800" lvl="4" marL="2286000">
+            <a:lvl5pPr marL="2286000" lvl="4" indent="-304800">
               <a:spcBef>
                 <a:spcPts val="0"/>
               </a:spcBef>
@@ -3128,7 +3210,7 @@
               <a:buChar char="○"/>
               <a:defRPr sz="1200"/>
             </a:lvl5pPr>
-            <a:lvl6pPr indent="-304800" lvl="5" marL="2743200">
+            <a:lvl6pPr marL="2743200" lvl="5" indent="-304800">
               <a:spcBef>
                 <a:spcPts val="0"/>
               </a:spcBef>
@@ -3139,7 +3221,7 @@
               <a:buChar char="■"/>
               <a:defRPr sz="1200"/>
             </a:lvl6pPr>
-            <a:lvl7pPr indent="-304800" lvl="6" marL="3200400">
+            <a:lvl7pPr marL="3200400" lvl="6" indent="-304800">
               <a:spcBef>
                 <a:spcPts val="0"/>
               </a:spcBef>
@@ -3150,7 +3232,7 @@
               <a:buChar char="●"/>
               <a:defRPr sz="1200"/>
             </a:lvl7pPr>
-            <a:lvl8pPr indent="-304800" lvl="7" marL="3657600">
+            <a:lvl8pPr marL="3657600" lvl="7" indent="-304800">
               <a:spcBef>
                 <a:spcPts val="0"/>
               </a:spcBef>
@@ -3161,7 +3243,7 @@
               <a:buChar char="○"/>
               <a:defRPr sz="1200"/>
             </a:lvl8pPr>
-            <a:lvl9pPr indent="-304800" lvl="8" marL="4114800">
+            <a:lvl9pPr marL="4114800" lvl="8" indent="-304800">
               <a:spcBef>
                 <a:spcPts val="0"/>
               </a:spcBef>
@@ -3173,15 +3255,19 @@
               <a:defRPr sz="1200"/>
             </a:lvl9pPr>
           </a:lstStyle>
-          <a:p/>
+          <a:p>
+            <a:endParaRPr/>
+          </a:p>
         </p:txBody>
       </p:sp>
       <p:sp>
         <p:nvSpPr>
           <p:cNvPr id="31" name="Google Shape;31;p7"/>
-          <p:cNvSpPr txBox="1"/>
+          <p:cNvSpPr txBox="1">
+            <a:spLocks noGrp="1"/>
+          </p:cNvSpPr>
           <p:nvPr>
-            <p:ph idx="12" type="sldNum"/>
+            <p:ph type="sldNum" idx="12"/>
           </p:nvPr>
         </p:nvSpPr>
         <p:spPr>
@@ -3194,7 +3280,7 @@
           </a:prstGeom>
         </p:spPr>
         <p:txBody>
-          <a:bodyPr anchorCtr="0" anchor="ctr" bIns="91425" lIns="91425" spcFirstLastPara="1" rIns="91425" wrap="square" tIns="91425">
+          <a:bodyPr spcFirstLastPara="1" wrap="square" lIns="91425" tIns="91425" rIns="91425" bIns="91425" anchor="ctr" anchorCtr="0">
             <a:normAutofit/>
           </a:bodyPr>
           <a:lstStyle>
@@ -3236,7 +3322,7 @@
             </a:lvl9pPr>
           </a:lstStyle>
           <a:p>
-            <a:pPr indent="0" lvl="0" marL="0" rtl="0" algn="r">
+            <a:pPr marL="0" lvl="0" indent="0" algn="r" rtl="0">
               <a:spcBef>
                 <a:spcPts val="0"/>
               </a:spcBef>
@@ -3262,11 +3348,11 @@
 </file>
 
 <file path=ppt/slideLayouts/slideLayout7.xml><?xml version="1.0" encoding="utf-8"?>
-<p:sldLayout xmlns:a="http://schemas.openxmlformats.org/drawingml/2006/main" xmlns:r="http://schemas.openxmlformats.org/officeDocument/2006/relationships" xmlns:mc="http://schemas.openxmlformats.org/markup-compatibility/2006" xmlns:mv="urn:schemas-microsoft-com:mac:vml" xmlns:p="http://schemas.openxmlformats.org/presentationml/2006/main" xmlns:c="http://schemas.openxmlformats.org/drawingml/2006/chart" xmlns:dgm="http://schemas.openxmlformats.org/drawingml/2006/diagram" xmlns:o="urn:schemas-microsoft-com:office:office" xmlns:v="urn:schemas-microsoft-com:vml" xmlns:pvml="urn:schemas-microsoft-com:office:powerpoint" xmlns:com="http://schemas.openxmlformats.org/drawingml/2006/compatibility" xmlns:p14="http://schemas.microsoft.com/office/powerpoint/2010/main" xmlns:p15="http://schemas.microsoft.com/office/powerpoint/2012/main" xmlns:ahyp="http://schemas.microsoft.com/office/drawing/2018/hyperlinkcolor" matchingName="Main point">
+<p:sldLayout xmlns:a="http://schemas.openxmlformats.org/drawingml/2006/main" xmlns:r="http://schemas.openxmlformats.org/officeDocument/2006/relationships" xmlns:p="http://schemas.openxmlformats.org/presentationml/2006/main" matchingName="Main point">
   <p:cSld name="MAIN_POINT">
     <p:spTree>
       <p:nvGrpSpPr>
-        <p:cNvPr id="32" name="Shape 32"/>
+        <p:cNvPr id="1" name="Shape 32"/>
         <p:cNvGrpSpPr/>
         <p:nvPr/>
       </p:nvGrpSpPr>
@@ -3281,7 +3367,9 @@
       <p:sp>
         <p:nvSpPr>
           <p:cNvPr id="33" name="Google Shape;33;p8"/>
-          <p:cNvSpPr txBox="1"/>
+          <p:cNvSpPr txBox="1">
+            <a:spLocks noGrp="1"/>
+          </p:cNvSpPr>
           <p:nvPr>
             <p:ph type="title"/>
           </p:nvPr>
@@ -3296,7 +3384,7 @@
           </a:prstGeom>
         </p:spPr>
         <p:txBody>
-          <a:bodyPr anchorCtr="0" anchor="ctr" bIns="91425" lIns="91425" spcFirstLastPara="1" rIns="91425" wrap="square" tIns="91425">
+          <a:bodyPr spcFirstLastPara="1" wrap="square" lIns="91425" tIns="91425" rIns="91425" bIns="91425" anchor="ctr" anchorCtr="0">
             <a:normAutofit/>
           </a:bodyPr>
           <a:lstStyle>
@@ -3400,15 +3488,19 @@
               <a:defRPr sz="4800"/>
             </a:lvl9pPr>
           </a:lstStyle>
-          <a:p/>
+          <a:p>
+            <a:endParaRPr/>
+          </a:p>
         </p:txBody>
       </p:sp>
       <p:sp>
         <p:nvSpPr>
           <p:cNvPr id="34" name="Google Shape;34;p8"/>
-          <p:cNvSpPr txBox="1"/>
+          <p:cNvSpPr txBox="1">
+            <a:spLocks noGrp="1"/>
+          </p:cNvSpPr>
           <p:nvPr>
-            <p:ph idx="12" type="sldNum"/>
+            <p:ph type="sldNum" idx="12"/>
           </p:nvPr>
         </p:nvSpPr>
         <p:spPr>
@@ -3421,7 +3513,7 @@
           </a:prstGeom>
         </p:spPr>
         <p:txBody>
-          <a:bodyPr anchorCtr="0" anchor="ctr" bIns="91425" lIns="91425" spcFirstLastPara="1" rIns="91425" wrap="square" tIns="91425">
+          <a:bodyPr spcFirstLastPara="1" wrap="square" lIns="91425" tIns="91425" rIns="91425" bIns="91425" anchor="ctr" anchorCtr="0">
             <a:normAutofit/>
           </a:bodyPr>
           <a:lstStyle>
@@ -3463,7 +3555,7 @@
             </a:lvl9pPr>
           </a:lstStyle>
           <a:p>
-            <a:pPr indent="0" lvl="0" marL="0" rtl="0" algn="r">
+            <a:pPr marL="0" lvl="0" indent="0" algn="r" rtl="0">
               <a:spcBef>
                 <a:spcPts val="0"/>
               </a:spcBef>
@@ -3489,11 +3581,11 @@
 </file>
 
 <file path=ppt/slideLayouts/slideLayout8.xml><?xml version="1.0" encoding="utf-8"?>
-<p:sldLayout xmlns:a="http://schemas.openxmlformats.org/drawingml/2006/main" xmlns:r="http://schemas.openxmlformats.org/officeDocument/2006/relationships" xmlns:mc="http://schemas.openxmlformats.org/markup-compatibility/2006" xmlns:mv="urn:schemas-microsoft-com:mac:vml" xmlns:p="http://schemas.openxmlformats.org/presentationml/2006/main" xmlns:c="http://schemas.openxmlformats.org/drawingml/2006/chart" xmlns:dgm="http://schemas.openxmlformats.org/drawingml/2006/diagram" xmlns:o="urn:schemas-microsoft-com:office:office" xmlns:v="urn:schemas-microsoft-com:vml" xmlns:pvml="urn:schemas-microsoft-com:office:powerpoint" xmlns:com="http://schemas.openxmlformats.org/drawingml/2006/compatibility" xmlns:p14="http://schemas.microsoft.com/office/powerpoint/2010/main" xmlns:p15="http://schemas.microsoft.com/office/powerpoint/2012/main" xmlns:ahyp="http://schemas.microsoft.com/office/drawing/2018/hyperlinkcolor" matchingName="Section title and description">
+<p:sldLayout xmlns:a="http://schemas.openxmlformats.org/drawingml/2006/main" xmlns:r="http://schemas.openxmlformats.org/officeDocument/2006/relationships" xmlns:p="http://schemas.openxmlformats.org/presentationml/2006/main" matchingName="Section title and description">
   <p:cSld name="SECTION_TITLE_AND_DESCRIPTION">
     <p:spTree>
       <p:nvGrpSpPr>
-        <p:cNvPr id="35" name="Shape 35"/>
+        <p:cNvPr id="1" name="Shape 35"/>
         <p:cNvGrpSpPr/>
         <p:nvPr/>
       </p:nvGrpSpPr>
@@ -3527,12 +3619,12 @@
           </a:ln>
         </p:spPr>
         <p:txBody>
-          <a:bodyPr anchorCtr="0" anchor="ctr" bIns="91425" lIns="91425" spcFirstLastPara="1" rIns="91425" wrap="square" tIns="91425">
+          <a:bodyPr spcFirstLastPara="1" wrap="square" lIns="91425" tIns="91425" rIns="91425" bIns="91425" anchor="ctr" anchorCtr="0">
             <a:noAutofit/>
           </a:bodyPr>
           <a:lstStyle/>
           <a:p>
-            <a:pPr indent="0" lvl="0" marL="0" rtl="0" algn="l">
+            <a:pPr marL="0" lvl="0" indent="0" algn="l" rtl="0">
               <a:spcBef>
                 <a:spcPts val="0"/>
               </a:spcBef>
@@ -3541,9 +3633,6 @@
               </a:spcAft>
               <a:buNone/>
             </a:pPr>
-            <a:r>
-              <a:t/>
-            </a:r>
             <a:endParaRPr/>
           </a:p>
         </p:txBody>
@@ -3551,7 +3640,9 @@
       <p:sp>
         <p:nvSpPr>
           <p:cNvPr id="37" name="Google Shape;37;p9"/>
-          <p:cNvSpPr txBox="1"/>
+          <p:cNvSpPr txBox="1">
+            <a:spLocks noGrp="1"/>
+          </p:cNvSpPr>
           <p:nvPr>
             <p:ph type="title"/>
           </p:nvPr>
@@ -3566,7 +3657,7 @@
           </a:prstGeom>
         </p:spPr>
         <p:txBody>
-          <a:bodyPr anchorCtr="0" anchor="b" bIns="91425" lIns="91425" spcFirstLastPara="1" rIns="91425" wrap="square" tIns="91425">
+          <a:bodyPr spcFirstLastPara="1" wrap="square" lIns="91425" tIns="91425" rIns="91425" bIns="91425" anchor="b" anchorCtr="0">
             <a:normAutofit/>
           </a:bodyPr>
           <a:lstStyle>
@@ -3670,15 +3761,19 @@
               <a:defRPr sz="4200"/>
             </a:lvl9pPr>
           </a:lstStyle>
-          <a:p/>
+          <a:p>
+            <a:endParaRPr/>
+          </a:p>
         </p:txBody>
       </p:sp>
       <p:sp>
         <p:nvSpPr>
           <p:cNvPr id="38" name="Google Shape;38;p9"/>
-          <p:cNvSpPr txBox="1"/>
+          <p:cNvSpPr txBox="1">
+            <a:spLocks noGrp="1"/>
+          </p:cNvSpPr>
           <p:nvPr>
-            <p:ph idx="1" type="subTitle"/>
+            <p:ph type="subTitle" idx="1"/>
           </p:nvPr>
         </p:nvSpPr>
         <p:spPr>
@@ -3691,7 +3786,7 @@
           </a:prstGeom>
         </p:spPr>
         <p:txBody>
-          <a:bodyPr anchorCtr="0" anchor="t" bIns="91425" lIns="91425" spcFirstLastPara="1" rIns="91425" wrap="square" tIns="91425">
+          <a:bodyPr spcFirstLastPara="1" wrap="square" lIns="91425" tIns="91425" rIns="91425" bIns="91425" anchor="t" anchorCtr="0">
             <a:normAutofit/>
           </a:bodyPr>
           <a:lstStyle>
@@ -3822,15 +3917,19 @@
               <a:defRPr sz="2100"/>
             </a:lvl9pPr>
           </a:lstStyle>
-          <a:p/>
+          <a:p>
+            <a:endParaRPr/>
+          </a:p>
         </p:txBody>
       </p:sp>
       <p:sp>
         <p:nvSpPr>
           <p:cNvPr id="39" name="Google Shape;39;p9"/>
-          <p:cNvSpPr txBox="1"/>
+          <p:cNvSpPr txBox="1">
+            <a:spLocks noGrp="1"/>
+          </p:cNvSpPr>
           <p:nvPr>
-            <p:ph idx="2" type="body"/>
+            <p:ph type="body" idx="2"/>
           </p:nvPr>
         </p:nvSpPr>
         <p:spPr>
@@ -3843,11 +3942,11 @@
           </a:prstGeom>
         </p:spPr>
         <p:txBody>
-          <a:bodyPr anchorCtr="0" anchor="ctr" bIns="91425" lIns="91425" spcFirstLastPara="1" rIns="91425" wrap="square" tIns="91425">
+          <a:bodyPr spcFirstLastPara="1" wrap="square" lIns="91425" tIns="91425" rIns="91425" bIns="91425" anchor="ctr" anchorCtr="0">
             <a:normAutofit/>
           </a:bodyPr>
           <a:lstStyle>
-            <a:lvl1pPr indent="-342900" lvl="0" marL="457200">
+            <a:lvl1pPr marL="457200" lvl="0" indent="-342900">
               <a:spcBef>
                 <a:spcPts val="0"/>
               </a:spcBef>
@@ -3858,7 +3957,7 @@
               <a:buChar char="●"/>
               <a:defRPr/>
             </a:lvl1pPr>
-            <a:lvl2pPr indent="-317500" lvl="1" marL="914400">
+            <a:lvl2pPr marL="914400" lvl="1" indent="-317500">
               <a:spcBef>
                 <a:spcPts val="0"/>
               </a:spcBef>
@@ -3869,7 +3968,7 @@
               <a:buChar char="○"/>
               <a:defRPr/>
             </a:lvl2pPr>
-            <a:lvl3pPr indent="-317500" lvl="2" marL="1371600">
+            <a:lvl3pPr marL="1371600" lvl="2" indent="-317500">
               <a:spcBef>
                 <a:spcPts val="0"/>
               </a:spcBef>
@@ -3880,7 +3979,7 @@
               <a:buChar char="■"/>
               <a:defRPr/>
             </a:lvl3pPr>
-            <a:lvl4pPr indent="-317500" lvl="3" marL="1828800">
+            <a:lvl4pPr marL="1828800" lvl="3" indent="-317500">
               <a:spcBef>
                 <a:spcPts val="0"/>
               </a:spcBef>
@@ -3891,7 +3990,7 @@
               <a:buChar char="●"/>
               <a:defRPr/>
             </a:lvl4pPr>
-            <a:lvl5pPr indent="-317500" lvl="4" marL="2286000">
+            <a:lvl5pPr marL="2286000" lvl="4" indent="-317500">
               <a:spcBef>
                 <a:spcPts val="0"/>
               </a:spcBef>
@@ -3902,7 +4001,7 @@
               <a:buChar char="○"/>
               <a:defRPr/>
             </a:lvl5pPr>
-            <a:lvl6pPr indent="-317500" lvl="5" marL="2743200">
+            <a:lvl6pPr marL="2743200" lvl="5" indent="-317500">
               <a:spcBef>
                 <a:spcPts val="0"/>
               </a:spcBef>
@@ -3913,7 +4012,7 @@
               <a:buChar char="■"/>
               <a:defRPr/>
             </a:lvl6pPr>
-            <a:lvl7pPr indent="-317500" lvl="6" marL="3200400">
+            <a:lvl7pPr marL="3200400" lvl="6" indent="-317500">
               <a:spcBef>
                 <a:spcPts val="0"/>
               </a:spcBef>
@@ -3924,7 +4023,7 @@
               <a:buChar char="●"/>
               <a:defRPr/>
             </a:lvl7pPr>
-            <a:lvl8pPr indent="-317500" lvl="7" marL="3657600">
+            <a:lvl8pPr marL="3657600" lvl="7" indent="-317500">
               <a:spcBef>
                 <a:spcPts val="0"/>
               </a:spcBef>
@@ -3935,7 +4034,7 @@
               <a:buChar char="○"/>
               <a:defRPr/>
             </a:lvl8pPr>
-            <a:lvl9pPr indent="-317500" lvl="8" marL="4114800">
+            <a:lvl9pPr marL="4114800" lvl="8" indent="-317500">
               <a:spcBef>
                 <a:spcPts val="0"/>
               </a:spcBef>
@@ -3947,15 +4046,19 @@
               <a:defRPr/>
             </a:lvl9pPr>
           </a:lstStyle>
-          <a:p/>
+          <a:p>
+            <a:endParaRPr/>
+          </a:p>
         </p:txBody>
       </p:sp>
       <p:sp>
         <p:nvSpPr>
           <p:cNvPr id="40" name="Google Shape;40;p9"/>
-          <p:cNvSpPr txBox="1"/>
+          <p:cNvSpPr txBox="1">
+            <a:spLocks noGrp="1"/>
+          </p:cNvSpPr>
           <p:nvPr>
-            <p:ph idx="12" type="sldNum"/>
+            <p:ph type="sldNum" idx="12"/>
           </p:nvPr>
         </p:nvSpPr>
         <p:spPr>
@@ -3968,7 +4071,7 @@
           </a:prstGeom>
         </p:spPr>
         <p:txBody>
-          <a:bodyPr anchorCtr="0" anchor="ctr" bIns="91425" lIns="91425" spcFirstLastPara="1" rIns="91425" wrap="square" tIns="91425">
+          <a:bodyPr spcFirstLastPara="1" wrap="square" lIns="91425" tIns="91425" rIns="91425" bIns="91425" anchor="ctr" anchorCtr="0">
             <a:normAutofit/>
           </a:bodyPr>
           <a:lstStyle>
@@ -4010,7 +4113,7 @@
             </a:lvl9pPr>
           </a:lstStyle>
           <a:p>
-            <a:pPr indent="0" lvl="0" marL="0" rtl="0" algn="r">
+            <a:pPr marL="0" lvl="0" indent="0" algn="r" rtl="0">
               <a:spcBef>
                 <a:spcPts val="0"/>
               </a:spcBef>
@@ -4036,11 +4139,11 @@
 </file>
 
 <file path=ppt/slideLayouts/slideLayout9.xml><?xml version="1.0" encoding="utf-8"?>
-<p:sldLayout xmlns:a="http://schemas.openxmlformats.org/drawingml/2006/main" xmlns:r="http://schemas.openxmlformats.org/officeDocument/2006/relationships" xmlns:mc="http://schemas.openxmlformats.org/markup-compatibility/2006" xmlns:mv="urn:schemas-microsoft-com:mac:vml" xmlns:p="http://schemas.openxmlformats.org/presentationml/2006/main" xmlns:c="http://schemas.openxmlformats.org/drawingml/2006/chart" xmlns:dgm="http://schemas.openxmlformats.org/drawingml/2006/diagram" xmlns:o="urn:schemas-microsoft-com:office:office" xmlns:v="urn:schemas-microsoft-com:vml" xmlns:pvml="urn:schemas-microsoft-com:office:powerpoint" xmlns:com="http://schemas.openxmlformats.org/drawingml/2006/compatibility" xmlns:p14="http://schemas.microsoft.com/office/powerpoint/2010/main" xmlns:p15="http://schemas.microsoft.com/office/powerpoint/2012/main" xmlns:ahyp="http://schemas.microsoft.com/office/drawing/2018/hyperlinkcolor" matchingName="Caption">
+<p:sldLayout xmlns:a="http://schemas.openxmlformats.org/drawingml/2006/main" xmlns:r="http://schemas.openxmlformats.org/officeDocument/2006/relationships" xmlns:p="http://schemas.openxmlformats.org/presentationml/2006/main" matchingName="Caption">
   <p:cSld name="CAPTION_ONLY">
     <p:spTree>
       <p:nvGrpSpPr>
-        <p:cNvPr id="41" name="Shape 41"/>
+        <p:cNvPr id="1" name="Shape 41"/>
         <p:cNvGrpSpPr/>
         <p:nvPr/>
       </p:nvGrpSpPr>
@@ -4055,9 +4158,11 @@
       <p:sp>
         <p:nvSpPr>
           <p:cNvPr id="42" name="Google Shape;42;p10"/>
-          <p:cNvSpPr txBox="1"/>
+          <p:cNvSpPr txBox="1">
+            <a:spLocks noGrp="1"/>
+          </p:cNvSpPr>
           <p:nvPr>
-            <p:ph idx="1" type="body"/>
+            <p:ph type="body" idx="1"/>
           </p:nvPr>
         </p:nvSpPr>
         <p:spPr>
@@ -4070,11 +4175,11 @@
           </a:prstGeom>
         </p:spPr>
         <p:txBody>
-          <a:bodyPr anchorCtr="0" anchor="ctr" bIns="91425" lIns="91425" spcFirstLastPara="1" rIns="91425" wrap="square" tIns="91425">
+          <a:bodyPr spcFirstLastPara="1" wrap="square" lIns="91425" tIns="91425" rIns="91425" bIns="91425" anchor="ctr" anchorCtr="0">
             <a:normAutofit/>
           </a:bodyPr>
           <a:lstStyle>
-            <a:lvl1pPr indent="-228600" lvl="0" marL="457200">
+            <a:lvl1pPr marL="457200" lvl="0" indent="-228600">
               <a:lnSpc>
                 <a:spcPct val="100000"/>
               </a:lnSpc>
@@ -4089,15 +4194,19 @@
               <a:defRPr/>
             </a:lvl1pPr>
           </a:lstStyle>
-          <a:p/>
+          <a:p>
+            <a:endParaRPr/>
+          </a:p>
         </p:txBody>
       </p:sp>
       <p:sp>
         <p:nvSpPr>
           <p:cNvPr id="43" name="Google Shape;43;p10"/>
-          <p:cNvSpPr txBox="1"/>
+          <p:cNvSpPr txBox="1">
+            <a:spLocks noGrp="1"/>
+          </p:cNvSpPr>
           <p:nvPr>
-            <p:ph idx="12" type="sldNum"/>
+            <p:ph type="sldNum" idx="12"/>
           </p:nvPr>
         </p:nvSpPr>
         <p:spPr>
@@ -4110,7 +4219,7 @@
           </a:prstGeom>
         </p:spPr>
         <p:txBody>
-          <a:bodyPr anchorCtr="0" anchor="ctr" bIns="91425" lIns="91425" spcFirstLastPara="1" rIns="91425" wrap="square" tIns="91425">
+          <a:bodyPr spcFirstLastPara="1" wrap="square" lIns="91425" tIns="91425" rIns="91425" bIns="91425" anchor="ctr" anchorCtr="0">
             <a:normAutofit/>
           </a:bodyPr>
           <a:lstStyle>
@@ -4152,7 +4261,7 @@
             </a:lvl9pPr>
           </a:lstStyle>
           <a:p>
-            <a:pPr indent="0" lvl="0" marL="0" rtl="0" algn="r">
+            <a:pPr marL="0" lvl="0" indent="0" algn="r" rtl="0">
               <a:spcBef>
                 <a:spcPts val="0"/>
               </a:spcBef>
@@ -4178,18 +4287,19 @@
 </file>
 
 <file path=ppt/slideMasters/slideMaster1.xml><?xml version="1.0" encoding="utf-8"?>
-<p:sldMaster xmlns:a="http://schemas.openxmlformats.org/drawingml/2006/main" xmlns:r="http://schemas.openxmlformats.org/officeDocument/2006/relationships" xmlns:mc="http://schemas.openxmlformats.org/markup-compatibility/2006" xmlns:mv="urn:schemas-microsoft-com:mac:vml" xmlns:p="http://schemas.openxmlformats.org/presentationml/2006/main" xmlns:c="http://schemas.openxmlformats.org/drawingml/2006/chart" xmlns:dgm="http://schemas.openxmlformats.org/drawingml/2006/diagram" xmlns:o="urn:schemas-microsoft-com:office:office" xmlns:v="urn:schemas-microsoft-com:vml" xmlns:pvml="urn:schemas-microsoft-com:office:powerpoint" xmlns:com="http://schemas.openxmlformats.org/drawingml/2006/compatibility" xmlns:p14="http://schemas.microsoft.com/office/powerpoint/2010/main" xmlns:p15="http://schemas.microsoft.com/office/powerpoint/2012/main" xmlns:ahyp="http://schemas.microsoft.com/office/drawing/2018/hyperlinkcolor">
+<p:sldMaster xmlns:a="http://schemas.openxmlformats.org/drawingml/2006/main" xmlns:r="http://schemas.openxmlformats.org/officeDocument/2006/relationships" xmlns:p="http://schemas.openxmlformats.org/presentationml/2006/main">
   <p:cSld name="simple-light-2">
     <p:bg>
       <p:bgPr>
         <a:solidFill>
           <a:schemeClr val="lt1"/>
         </a:solidFill>
+        <a:effectLst/>
       </p:bgPr>
     </p:bg>
     <p:spTree>
       <p:nvGrpSpPr>
-        <p:cNvPr id="5" name="Shape 5"/>
+        <p:cNvPr id="1" name="Shape 5"/>
         <p:cNvGrpSpPr/>
         <p:nvPr/>
       </p:nvGrpSpPr>
@@ -4204,7 +4314,9 @@
       <p:sp>
         <p:nvSpPr>
           <p:cNvPr id="6" name="Google Shape;6;p1"/>
-          <p:cNvSpPr txBox="1"/>
+          <p:cNvSpPr txBox="1">
+            <a:spLocks noGrp="1"/>
+          </p:cNvSpPr>
           <p:nvPr>
             <p:ph type="title"/>
           </p:nvPr>
@@ -4223,7 +4335,7 @@
           </a:ln>
         </p:spPr>
         <p:txBody>
-          <a:bodyPr anchorCtr="0" anchor="t" bIns="91425" lIns="91425" spcFirstLastPara="1" rIns="91425" wrap="square" tIns="91425">
+          <a:bodyPr spcFirstLastPara="1" wrap="square" lIns="91425" tIns="91425" rIns="91425" bIns="91425" anchor="t" anchorCtr="0">
             <a:normAutofit/>
           </a:bodyPr>
           <a:lstStyle>
@@ -4390,15 +4502,19 @@
               </a:defRPr>
             </a:lvl9pPr>
           </a:lstStyle>
-          <a:p/>
+          <a:p>
+            <a:endParaRPr/>
+          </a:p>
         </p:txBody>
       </p:sp>
       <p:sp>
         <p:nvSpPr>
           <p:cNvPr id="7" name="Google Shape;7;p1"/>
-          <p:cNvSpPr txBox="1"/>
+          <p:cNvSpPr txBox="1">
+            <a:spLocks noGrp="1"/>
+          </p:cNvSpPr>
           <p:nvPr>
-            <p:ph idx="1" type="body"/>
+            <p:ph type="body" idx="1"/>
           </p:nvPr>
         </p:nvSpPr>
         <p:spPr>
@@ -4415,11 +4531,11 @@
           </a:ln>
         </p:spPr>
         <p:txBody>
-          <a:bodyPr anchorCtr="0" anchor="t" bIns="91425" lIns="91425" spcFirstLastPara="1" rIns="91425" wrap="square" tIns="91425">
+          <a:bodyPr spcFirstLastPara="1" wrap="square" lIns="91425" tIns="91425" rIns="91425" bIns="91425" anchor="t" anchorCtr="0">
             <a:normAutofit/>
           </a:bodyPr>
           <a:lstStyle>
-            <a:lvl1pPr indent="-342900" lvl="0" marL="457200">
+            <a:lvl1pPr marL="457200" lvl="0" indent="-342900">
               <a:lnSpc>
                 <a:spcPct val="115000"/>
               </a:lnSpc>
@@ -4440,7 +4556,7 @@
                 </a:solidFill>
               </a:defRPr>
             </a:lvl1pPr>
-            <a:lvl2pPr indent="-317500" lvl="1" marL="914400">
+            <a:lvl2pPr marL="914400" lvl="1" indent="-317500">
               <a:lnSpc>
                 <a:spcPct val="115000"/>
               </a:lnSpc>
@@ -4461,7 +4577,7 @@
                 </a:solidFill>
               </a:defRPr>
             </a:lvl2pPr>
-            <a:lvl3pPr indent="-317500" lvl="2" marL="1371600">
+            <a:lvl3pPr marL="1371600" lvl="2" indent="-317500">
               <a:lnSpc>
                 <a:spcPct val="115000"/>
               </a:lnSpc>
@@ -4482,7 +4598,7 @@
                 </a:solidFill>
               </a:defRPr>
             </a:lvl3pPr>
-            <a:lvl4pPr indent="-317500" lvl="3" marL="1828800">
+            <a:lvl4pPr marL="1828800" lvl="3" indent="-317500">
               <a:lnSpc>
                 <a:spcPct val="115000"/>
               </a:lnSpc>
@@ -4503,7 +4619,7 @@
                 </a:solidFill>
               </a:defRPr>
             </a:lvl4pPr>
-            <a:lvl5pPr indent="-317500" lvl="4" marL="2286000">
+            <a:lvl5pPr marL="2286000" lvl="4" indent="-317500">
               <a:lnSpc>
                 <a:spcPct val="115000"/>
               </a:lnSpc>
@@ -4524,7 +4640,7 @@
                 </a:solidFill>
               </a:defRPr>
             </a:lvl5pPr>
-            <a:lvl6pPr indent="-317500" lvl="5" marL="2743200">
+            <a:lvl6pPr marL="2743200" lvl="5" indent="-317500">
               <a:lnSpc>
                 <a:spcPct val="115000"/>
               </a:lnSpc>
@@ -4545,7 +4661,7 @@
                 </a:solidFill>
               </a:defRPr>
             </a:lvl6pPr>
-            <a:lvl7pPr indent="-317500" lvl="6" marL="3200400">
+            <a:lvl7pPr marL="3200400" lvl="6" indent="-317500">
               <a:lnSpc>
                 <a:spcPct val="115000"/>
               </a:lnSpc>
@@ -4566,7 +4682,7 @@
                 </a:solidFill>
               </a:defRPr>
             </a:lvl7pPr>
-            <a:lvl8pPr indent="-317500" lvl="7" marL="3657600">
+            <a:lvl8pPr marL="3657600" lvl="7" indent="-317500">
               <a:lnSpc>
                 <a:spcPct val="115000"/>
               </a:lnSpc>
@@ -4587,7 +4703,7 @@
                 </a:solidFill>
               </a:defRPr>
             </a:lvl8pPr>
-            <a:lvl9pPr indent="-317500" lvl="8" marL="4114800">
+            <a:lvl9pPr marL="4114800" lvl="8" indent="-317500">
               <a:lnSpc>
                 <a:spcPct val="115000"/>
               </a:lnSpc>
@@ -4609,15 +4725,19 @@
               </a:defRPr>
             </a:lvl9pPr>
           </a:lstStyle>
-          <a:p/>
+          <a:p>
+            <a:endParaRPr/>
+          </a:p>
         </p:txBody>
       </p:sp>
       <p:sp>
         <p:nvSpPr>
           <p:cNvPr id="8" name="Google Shape;8;p1"/>
-          <p:cNvSpPr txBox="1"/>
+          <p:cNvSpPr txBox="1">
+            <a:spLocks noGrp="1"/>
+          </p:cNvSpPr>
           <p:nvPr>
-            <p:ph idx="12" type="sldNum"/>
+            <p:ph type="sldNum" idx="12"/>
           </p:nvPr>
         </p:nvSpPr>
         <p:spPr>
@@ -4634,7 +4754,7 @@
           </a:ln>
         </p:spPr>
         <p:txBody>
-          <a:bodyPr anchorCtr="0" anchor="ctr" bIns="91425" lIns="91425" spcFirstLastPara="1" rIns="91425" wrap="square" tIns="91425">
+          <a:bodyPr spcFirstLastPara="1" wrap="square" lIns="91425" tIns="91425" rIns="91425" bIns="91425" anchor="ctr" anchorCtr="0">
             <a:normAutofit/>
           </a:bodyPr>
           <a:lstStyle>
@@ -4712,7 +4832,7 @@
             </a:lvl9pPr>
           </a:lstStyle>
           <a:p>
-            <a:pPr indent="0" lvl="0" marL="0" rtl="0" algn="r">
+            <a:pPr marL="0" lvl="0" indent="0" algn="r" rtl="0">
               <a:spcBef>
                 <a:spcPts val="0"/>
               </a:spcBef>
@@ -4731,7 +4851,7 @@
       </p:sp>
     </p:spTree>
   </p:cSld>
-  <p:clrMap accent1="accent1" accent2="accent2" accent3="accent3" accent4="accent4" accent5="accent5" accent6="accent6" bg1="lt1" bg2="dk2" tx1="dk1" tx2="lt2" folHlink="folHlink" hlink="hlink"/>
+  <p:clrMap bg1="lt1" tx1="dk1" bg2="dk2" tx2="lt2" accent1="accent1" accent2="accent2" accent3="accent3" accent4="accent4" accent5="accent5" accent6="accent6" hlink="hlink" folHlink="folHlink"/>
   <p:sldLayoutIdLst>
     <p:sldLayoutId id="2147483648" r:id="rId1"/>
     <p:sldLayoutId id="2147483649" r:id="rId2"/>
@@ -4745,10 +4865,10 @@
     <p:sldLayoutId id="2147483657" r:id="rId10"/>
     <p:sldLayoutId id="2147483658" r:id="rId11"/>
   </p:sldLayoutIdLst>
-  <p:hf dt="0" ftr="0" hdr="0" sldNum="0"/>
+  <p:hf sldNum="0" hdr="0" ftr="0" dt="0"/>
   <p:txStyles>
     <p:titleStyle>
-      <a:defPPr lvl="0" marR="0" rtl="0" algn="l">
+      <a:defPPr marR="0" lvl="0" algn="l" rtl="0">
         <a:lnSpc>
           <a:spcPct val="100000"/>
         </a:lnSpc>
@@ -4759,7 +4879,7 @@
           <a:spcPts val="0"/>
         </a:spcAft>
       </a:defPPr>
-      <a:lvl1pPr lvl="0" marR="0" rtl="0" algn="l">
+      <a:lvl1pPr marR="0" lvl="0" algn="l" rtl="0">
         <a:lnSpc>
           <a:spcPct val="100000"/>
         </a:lnSpc>
@@ -4773,7 +4893,7 @@
           <a:srgbClr val="000000"/>
         </a:buClr>
         <a:buFont typeface="Arial"/>
-        <a:defRPr b="0" i="0" sz="1400" u="none" cap="none" strike="noStrike">
+        <a:defRPr sz="1400" b="0" i="0" u="none" strike="noStrike" cap="none">
           <a:solidFill>
             <a:srgbClr val="000000"/>
           </a:solidFill>
@@ -4783,7 +4903,7 @@
           <a:sym typeface="Arial"/>
         </a:defRPr>
       </a:lvl1pPr>
-      <a:lvl2pPr lvl="1" marR="0" rtl="0" algn="l">
+      <a:lvl2pPr marR="0" lvl="1" algn="l" rtl="0">
         <a:lnSpc>
           <a:spcPct val="100000"/>
         </a:lnSpc>
@@ -4797,7 +4917,7 @@
           <a:srgbClr val="000000"/>
         </a:buClr>
         <a:buFont typeface="Arial"/>
-        <a:defRPr b="0" i="0" sz="1400" u="none" cap="none" strike="noStrike">
+        <a:defRPr sz="1400" b="0" i="0" u="none" strike="noStrike" cap="none">
           <a:solidFill>
             <a:srgbClr val="000000"/>
           </a:solidFill>
@@ -4807,7 +4927,7 @@
           <a:sym typeface="Arial"/>
         </a:defRPr>
       </a:lvl2pPr>
-      <a:lvl3pPr lvl="2" marR="0" rtl="0" algn="l">
+      <a:lvl3pPr marR="0" lvl="2" algn="l" rtl="0">
         <a:lnSpc>
           <a:spcPct val="100000"/>
         </a:lnSpc>
@@ -4821,7 +4941,7 @@
           <a:srgbClr val="000000"/>
         </a:buClr>
         <a:buFont typeface="Arial"/>
-        <a:defRPr b="0" i="0" sz="1400" u="none" cap="none" strike="noStrike">
+        <a:defRPr sz="1400" b="0" i="0" u="none" strike="noStrike" cap="none">
           <a:solidFill>
             <a:srgbClr val="000000"/>
           </a:solidFill>
@@ -4831,7 +4951,7 @@
           <a:sym typeface="Arial"/>
         </a:defRPr>
       </a:lvl3pPr>
-      <a:lvl4pPr lvl="3" marR="0" rtl="0" algn="l">
+      <a:lvl4pPr marR="0" lvl="3" algn="l" rtl="0">
         <a:lnSpc>
           <a:spcPct val="100000"/>
         </a:lnSpc>
@@ -4845,7 +4965,7 @@
           <a:srgbClr val="000000"/>
         </a:buClr>
         <a:buFont typeface="Arial"/>
-        <a:defRPr b="0" i="0" sz="1400" u="none" cap="none" strike="noStrike">
+        <a:defRPr sz="1400" b="0" i="0" u="none" strike="noStrike" cap="none">
           <a:solidFill>
             <a:srgbClr val="000000"/>
           </a:solidFill>
@@ -4855,7 +4975,7 @@
           <a:sym typeface="Arial"/>
         </a:defRPr>
       </a:lvl4pPr>
-      <a:lvl5pPr lvl="4" marR="0" rtl="0" algn="l">
+      <a:lvl5pPr marR="0" lvl="4" algn="l" rtl="0">
         <a:lnSpc>
           <a:spcPct val="100000"/>
         </a:lnSpc>
@@ -4869,7 +4989,7 @@
           <a:srgbClr val="000000"/>
         </a:buClr>
         <a:buFont typeface="Arial"/>
-        <a:defRPr b="0" i="0" sz="1400" u="none" cap="none" strike="noStrike">
+        <a:defRPr sz="1400" b="0" i="0" u="none" strike="noStrike" cap="none">
           <a:solidFill>
             <a:srgbClr val="000000"/>
           </a:solidFill>
@@ -4879,7 +4999,7 @@
           <a:sym typeface="Arial"/>
         </a:defRPr>
       </a:lvl5pPr>
-      <a:lvl6pPr lvl="5" marR="0" rtl="0" algn="l">
+      <a:lvl6pPr marR="0" lvl="5" algn="l" rtl="0">
         <a:lnSpc>
           <a:spcPct val="100000"/>
         </a:lnSpc>
@@ -4893,7 +5013,7 @@
           <a:srgbClr val="000000"/>
         </a:buClr>
         <a:buFont typeface="Arial"/>
-        <a:defRPr b="0" i="0" sz="1400" u="none" cap="none" strike="noStrike">
+        <a:defRPr sz="1400" b="0" i="0" u="none" strike="noStrike" cap="none">
           <a:solidFill>
             <a:srgbClr val="000000"/>
           </a:solidFill>
@@ -4903,7 +5023,7 @@
           <a:sym typeface="Arial"/>
         </a:defRPr>
       </a:lvl6pPr>
-      <a:lvl7pPr lvl="6" marR="0" rtl="0" algn="l">
+      <a:lvl7pPr marR="0" lvl="6" algn="l" rtl="0">
         <a:lnSpc>
           <a:spcPct val="100000"/>
         </a:lnSpc>
@@ -4917,7 +5037,7 @@
           <a:srgbClr val="000000"/>
         </a:buClr>
         <a:buFont typeface="Arial"/>
-        <a:defRPr b="0" i="0" sz="1400" u="none" cap="none" strike="noStrike">
+        <a:defRPr sz="1400" b="0" i="0" u="none" strike="noStrike" cap="none">
           <a:solidFill>
             <a:srgbClr val="000000"/>
           </a:solidFill>
@@ -4927,7 +5047,7 @@
           <a:sym typeface="Arial"/>
         </a:defRPr>
       </a:lvl7pPr>
-      <a:lvl8pPr lvl="7" marR="0" rtl="0" algn="l">
+      <a:lvl8pPr marR="0" lvl="7" algn="l" rtl="0">
         <a:lnSpc>
           <a:spcPct val="100000"/>
         </a:lnSpc>
@@ -4941,7 +5061,7 @@
           <a:srgbClr val="000000"/>
         </a:buClr>
         <a:buFont typeface="Arial"/>
-        <a:defRPr b="0" i="0" sz="1400" u="none" cap="none" strike="noStrike">
+        <a:defRPr sz="1400" b="0" i="0" u="none" strike="noStrike" cap="none">
           <a:solidFill>
             <a:srgbClr val="000000"/>
           </a:solidFill>
@@ -4951,7 +5071,7 @@
           <a:sym typeface="Arial"/>
         </a:defRPr>
       </a:lvl8pPr>
-      <a:lvl9pPr lvl="8" marR="0" rtl="0" algn="l">
+      <a:lvl9pPr marR="0" lvl="8" algn="l" rtl="0">
         <a:lnSpc>
           <a:spcPct val="100000"/>
         </a:lnSpc>
@@ -4965,7 +5085,7 @@
           <a:srgbClr val="000000"/>
         </a:buClr>
         <a:buFont typeface="Arial"/>
-        <a:defRPr b="0" i="0" sz="1400" u="none" cap="none" strike="noStrike">
+        <a:defRPr sz="1400" b="0" i="0" u="none" strike="noStrike" cap="none">
           <a:solidFill>
             <a:srgbClr val="000000"/>
           </a:solidFill>
@@ -4977,7 +5097,7 @@
       </a:lvl9pPr>
     </p:titleStyle>
     <p:bodyStyle>
-      <a:defPPr lvl="0" marR="0" rtl="0" algn="l">
+      <a:defPPr marR="0" lvl="0" algn="l" rtl="0">
         <a:lnSpc>
           <a:spcPct val="100000"/>
         </a:lnSpc>
@@ -4988,7 +5108,7 @@
           <a:spcPts val="0"/>
         </a:spcAft>
       </a:defPPr>
-      <a:lvl1pPr lvl="0" marR="0" rtl="0" algn="l">
+      <a:lvl1pPr marR="0" lvl="0" algn="l" rtl="0">
         <a:lnSpc>
           <a:spcPct val="100000"/>
         </a:lnSpc>
@@ -5002,7 +5122,7 @@
           <a:srgbClr val="000000"/>
         </a:buClr>
         <a:buFont typeface="Arial"/>
-        <a:defRPr b="0" i="0" sz="1400" u="none" cap="none" strike="noStrike">
+        <a:defRPr sz="1400" b="0" i="0" u="none" strike="noStrike" cap="none">
           <a:solidFill>
             <a:srgbClr val="000000"/>
           </a:solidFill>
@@ -5012,7 +5132,7 @@
           <a:sym typeface="Arial"/>
         </a:defRPr>
       </a:lvl1pPr>
-      <a:lvl2pPr lvl="1" marR="0" rtl="0" algn="l">
+      <a:lvl2pPr marR="0" lvl="1" algn="l" rtl="0">
         <a:lnSpc>
           <a:spcPct val="100000"/>
         </a:lnSpc>
@@ -5026,7 +5146,7 @@
           <a:srgbClr val="000000"/>
         </a:buClr>
         <a:buFont typeface="Arial"/>
-        <a:defRPr b="0" i="0" sz="1400" u="none" cap="none" strike="noStrike">
+        <a:defRPr sz="1400" b="0" i="0" u="none" strike="noStrike" cap="none">
           <a:solidFill>
             <a:srgbClr val="000000"/>
           </a:solidFill>
@@ -5036,7 +5156,7 @@
           <a:sym typeface="Arial"/>
         </a:defRPr>
       </a:lvl2pPr>
-      <a:lvl3pPr lvl="2" marR="0" rtl="0" algn="l">
+      <a:lvl3pPr marR="0" lvl="2" algn="l" rtl="0">
         <a:lnSpc>
           <a:spcPct val="100000"/>
         </a:lnSpc>
@@ -5050,7 +5170,7 @@
           <a:srgbClr val="000000"/>
         </a:buClr>
         <a:buFont typeface="Arial"/>
-        <a:defRPr b="0" i="0" sz="1400" u="none" cap="none" strike="noStrike">
+        <a:defRPr sz="1400" b="0" i="0" u="none" strike="noStrike" cap="none">
           <a:solidFill>
             <a:srgbClr val="000000"/>
           </a:solidFill>
@@ -5060,7 +5180,7 @@
           <a:sym typeface="Arial"/>
         </a:defRPr>
       </a:lvl3pPr>
-      <a:lvl4pPr lvl="3" marR="0" rtl="0" algn="l">
+      <a:lvl4pPr marR="0" lvl="3" algn="l" rtl="0">
         <a:lnSpc>
           <a:spcPct val="100000"/>
         </a:lnSpc>
@@ -5074,7 +5194,7 @@
           <a:srgbClr val="000000"/>
         </a:buClr>
         <a:buFont typeface="Arial"/>
-        <a:defRPr b="0" i="0" sz="1400" u="none" cap="none" strike="noStrike">
+        <a:defRPr sz="1400" b="0" i="0" u="none" strike="noStrike" cap="none">
           <a:solidFill>
             <a:srgbClr val="000000"/>
           </a:solidFill>
@@ -5084,7 +5204,7 @@
           <a:sym typeface="Arial"/>
         </a:defRPr>
       </a:lvl4pPr>
-      <a:lvl5pPr lvl="4" marR="0" rtl="0" algn="l">
+      <a:lvl5pPr marR="0" lvl="4" algn="l" rtl="0">
         <a:lnSpc>
           <a:spcPct val="100000"/>
         </a:lnSpc>
@@ -5098,7 +5218,7 @@
           <a:srgbClr val="000000"/>
         </a:buClr>
         <a:buFont typeface="Arial"/>
-        <a:defRPr b="0" i="0" sz="1400" u="none" cap="none" strike="noStrike">
+        <a:defRPr sz="1400" b="0" i="0" u="none" strike="noStrike" cap="none">
           <a:solidFill>
             <a:srgbClr val="000000"/>
           </a:solidFill>
@@ -5108,7 +5228,7 @@
           <a:sym typeface="Arial"/>
         </a:defRPr>
       </a:lvl5pPr>
-      <a:lvl6pPr lvl="5" marR="0" rtl="0" algn="l">
+      <a:lvl6pPr marR="0" lvl="5" algn="l" rtl="0">
         <a:lnSpc>
           <a:spcPct val="100000"/>
         </a:lnSpc>
@@ -5122,7 +5242,7 @@
           <a:srgbClr val="000000"/>
         </a:buClr>
         <a:buFont typeface="Arial"/>
-        <a:defRPr b="0" i="0" sz="1400" u="none" cap="none" strike="noStrike">
+        <a:defRPr sz="1400" b="0" i="0" u="none" strike="noStrike" cap="none">
           <a:solidFill>
             <a:srgbClr val="000000"/>
           </a:solidFill>
@@ -5132,7 +5252,7 @@
           <a:sym typeface="Arial"/>
         </a:defRPr>
       </a:lvl6pPr>
-      <a:lvl7pPr lvl="6" marR="0" rtl="0" algn="l">
+      <a:lvl7pPr marR="0" lvl="6" algn="l" rtl="0">
         <a:lnSpc>
           <a:spcPct val="100000"/>
         </a:lnSpc>
@@ -5146,7 +5266,7 @@
           <a:srgbClr val="000000"/>
         </a:buClr>
         <a:buFont typeface="Arial"/>
-        <a:defRPr b="0" i="0" sz="1400" u="none" cap="none" strike="noStrike">
+        <a:defRPr sz="1400" b="0" i="0" u="none" strike="noStrike" cap="none">
           <a:solidFill>
             <a:srgbClr val="000000"/>
           </a:solidFill>
@@ -5156,7 +5276,7 @@
           <a:sym typeface="Arial"/>
         </a:defRPr>
       </a:lvl7pPr>
-      <a:lvl8pPr lvl="7" marR="0" rtl="0" algn="l">
+      <a:lvl8pPr marR="0" lvl="7" algn="l" rtl="0">
         <a:lnSpc>
           <a:spcPct val="100000"/>
         </a:lnSpc>
@@ -5170,7 +5290,7 @@
           <a:srgbClr val="000000"/>
         </a:buClr>
         <a:buFont typeface="Arial"/>
-        <a:defRPr b="0" i="0" sz="1400" u="none" cap="none" strike="noStrike">
+        <a:defRPr sz="1400" b="0" i="0" u="none" strike="noStrike" cap="none">
           <a:solidFill>
             <a:srgbClr val="000000"/>
           </a:solidFill>
@@ -5180,7 +5300,7 @@
           <a:sym typeface="Arial"/>
         </a:defRPr>
       </a:lvl8pPr>
-      <a:lvl9pPr lvl="8" marR="0" rtl="0" algn="l">
+      <a:lvl9pPr marR="0" lvl="8" algn="l" rtl="0">
         <a:lnSpc>
           <a:spcPct val="100000"/>
         </a:lnSpc>
@@ -5194,7 +5314,7 @@
           <a:srgbClr val="000000"/>
         </a:buClr>
         <a:buFont typeface="Arial"/>
-        <a:defRPr b="0" i="0" sz="1400" u="none" cap="none" strike="noStrike">
+        <a:defRPr sz="1400" b="0" i="0" u="none" strike="noStrike" cap="none">
           <a:solidFill>
             <a:srgbClr val="000000"/>
           </a:solidFill>
@@ -5206,7 +5326,7 @@
       </a:lvl9pPr>
     </p:bodyStyle>
     <p:otherStyle>
-      <a:defPPr lvl="0" marR="0" rtl="0" algn="l">
+      <a:defPPr marR="0" lvl="0" algn="l" rtl="0">
         <a:lnSpc>
           <a:spcPct val="100000"/>
         </a:lnSpc>
@@ -5217,7 +5337,7 @@
           <a:spcPts val="0"/>
         </a:spcAft>
       </a:defPPr>
-      <a:lvl1pPr lvl="0" marR="0" rtl="0" algn="l">
+      <a:lvl1pPr marR="0" lvl="0" algn="l" rtl="0">
         <a:lnSpc>
           <a:spcPct val="100000"/>
         </a:lnSpc>
@@ -5231,7 +5351,7 @@
           <a:srgbClr val="000000"/>
         </a:buClr>
         <a:buFont typeface="Arial"/>
-        <a:defRPr b="0" i="0" sz="1400" u="none" cap="none" strike="noStrike">
+        <a:defRPr sz="1400" b="0" i="0" u="none" strike="noStrike" cap="none">
           <a:solidFill>
             <a:srgbClr val="000000"/>
           </a:solidFill>
@@ -5241,7 +5361,7 @@
           <a:sym typeface="Arial"/>
         </a:defRPr>
       </a:lvl1pPr>
-      <a:lvl2pPr lvl="1" marR="0" rtl="0" algn="l">
+      <a:lvl2pPr marR="0" lvl="1" algn="l" rtl="0">
         <a:lnSpc>
           <a:spcPct val="100000"/>
         </a:lnSpc>
@@ -5255,7 +5375,7 @@
           <a:srgbClr val="000000"/>
         </a:buClr>
         <a:buFont typeface="Arial"/>
-        <a:defRPr b="0" i="0" sz="1400" u="none" cap="none" strike="noStrike">
+        <a:defRPr sz="1400" b="0" i="0" u="none" strike="noStrike" cap="none">
           <a:solidFill>
             <a:srgbClr val="000000"/>
           </a:solidFill>
@@ -5265,7 +5385,7 @@
           <a:sym typeface="Arial"/>
         </a:defRPr>
       </a:lvl2pPr>
-      <a:lvl3pPr lvl="2" marR="0" rtl="0" algn="l">
+      <a:lvl3pPr marR="0" lvl="2" algn="l" rtl="0">
         <a:lnSpc>
           <a:spcPct val="100000"/>
         </a:lnSpc>
@@ -5279,7 +5399,7 @@
           <a:srgbClr val="000000"/>
         </a:buClr>
         <a:buFont typeface="Arial"/>
-        <a:defRPr b="0" i="0" sz="1400" u="none" cap="none" strike="noStrike">
+        <a:defRPr sz="1400" b="0" i="0" u="none" strike="noStrike" cap="none">
           <a:solidFill>
             <a:srgbClr val="000000"/>
           </a:solidFill>
@@ -5289,7 +5409,7 @@
           <a:sym typeface="Arial"/>
         </a:defRPr>
       </a:lvl3pPr>
-      <a:lvl4pPr lvl="3" marR="0" rtl="0" algn="l">
+      <a:lvl4pPr marR="0" lvl="3" algn="l" rtl="0">
         <a:lnSpc>
           <a:spcPct val="100000"/>
         </a:lnSpc>
@@ -5303,7 +5423,7 @@
           <a:srgbClr val="000000"/>
         </a:buClr>
         <a:buFont typeface="Arial"/>
-        <a:defRPr b="0" i="0" sz="1400" u="none" cap="none" strike="noStrike">
+        <a:defRPr sz="1400" b="0" i="0" u="none" strike="noStrike" cap="none">
           <a:solidFill>
             <a:srgbClr val="000000"/>
           </a:solidFill>
@@ -5313,7 +5433,7 @@
           <a:sym typeface="Arial"/>
         </a:defRPr>
       </a:lvl4pPr>
-      <a:lvl5pPr lvl="4" marR="0" rtl="0" algn="l">
+      <a:lvl5pPr marR="0" lvl="4" algn="l" rtl="0">
         <a:lnSpc>
           <a:spcPct val="100000"/>
         </a:lnSpc>
@@ -5327,7 +5447,7 @@
           <a:srgbClr val="000000"/>
         </a:buClr>
         <a:buFont typeface="Arial"/>
-        <a:defRPr b="0" i="0" sz="1400" u="none" cap="none" strike="noStrike">
+        <a:defRPr sz="1400" b="0" i="0" u="none" strike="noStrike" cap="none">
           <a:solidFill>
             <a:srgbClr val="000000"/>
           </a:solidFill>
@@ -5337,7 +5457,7 @@
           <a:sym typeface="Arial"/>
         </a:defRPr>
       </a:lvl5pPr>
-      <a:lvl6pPr lvl="5" marR="0" rtl="0" algn="l">
+      <a:lvl6pPr marR="0" lvl="5" algn="l" rtl="0">
         <a:lnSpc>
           <a:spcPct val="100000"/>
         </a:lnSpc>
@@ -5351,7 +5471,7 @@
           <a:srgbClr val="000000"/>
         </a:buClr>
         <a:buFont typeface="Arial"/>
-        <a:defRPr b="0" i="0" sz="1400" u="none" cap="none" strike="noStrike">
+        <a:defRPr sz="1400" b="0" i="0" u="none" strike="noStrike" cap="none">
           <a:solidFill>
             <a:srgbClr val="000000"/>
           </a:solidFill>
@@ -5361,7 +5481,7 @@
           <a:sym typeface="Arial"/>
         </a:defRPr>
       </a:lvl6pPr>
-      <a:lvl7pPr lvl="6" marR="0" rtl="0" algn="l">
+      <a:lvl7pPr marR="0" lvl="6" algn="l" rtl="0">
         <a:lnSpc>
           <a:spcPct val="100000"/>
         </a:lnSpc>
@@ -5375,7 +5495,7 @@
           <a:srgbClr val="000000"/>
         </a:buClr>
         <a:buFont typeface="Arial"/>
-        <a:defRPr b="0" i="0" sz="1400" u="none" cap="none" strike="noStrike">
+        <a:defRPr sz="1400" b="0" i="0" u="none" strike="noStrike" cap="none">
           <a:solidFill>
             <a:srgbClr val="000000"/>
           </a:solidFill>
@@ -5385,7 +5505,7 @@
           <a:sym typeface="Arial"/>
         </a:defRPr>
       </a:lvl7pPr>
-      <a:lvl8pPr lvl="7" marR="0" rtl="0" algn="l">
+      <a:lvl8pPr marR="0" lvl="7" algn="l" rtl="0">
         <a:lnSpc>
           <a:spcPct val="100000"/>
         </a:lnSpc>
@@ -5399,7 +5519,7 @@
           <a:srgbClr val="000000"/>
         </a:buClr>
         <a:buFont typeface="Arial"/>
-        <a:defRPr b="0" i="0" sz="1400" u="none" cap="none" strike="noStrike">
+        <a:defRPr sz="1400" b="0" i="0" u="none" strike="noStrike" cap="none">
           <a:solidFill>
             <a:srgbClr val="000000"/>
           </a:solidFill>
@@ -5409,7 +5529,7 @@
           <a:sym typeface="Arial"/>
         </a:defRPr>
       </a:lvl8pPr>
-      <a:lvl9pPr lvl="8" marR="0" rtl="0" algn="l">
+      <a:lvl9pPr marR="0" lvl="8" algn="l" rtl="0">
         <a:lnSpc>
           <a:spcPct val="100000"/>
         </a:lnSpc>
@@ -5423,7 +5543,7 @@
           <a:srgbClr val="000000"/>
         </a:buClr>
         <a:buFont typeface="Arial"/>
-        <a:defRPr b="0" i="0" sz="1400" u="none" cap="none" strike="noStrike">
+        <a:defRPr sz="1400" b="0" i="0" u="none" strike="noStrike" cap="none">
           <a:solidFill>
             <a:srgbClr val="000000"/>
           </a:solidFill>
@@ -5439,11 +5559,11 @@
 </file>
 
 <file path=ppt/slides/slide1.xml><?xml version="1.0" encoding="utf-8"?>
-<p:sld xmlns:a="http://schemas.openxmlformats.org/drawingml/2006/main" xmlns:r="http://schemas.openxmlformats.org/officeDocument/2006/relationships" xmlns:mc="http://schemas.openxmlformats.org/markup-compatibility/2006" xmlns:mv="urn:schemas-microsoft-com:mac:vml" xmlns:p="http://schemas.openxmlformats.org/presentationml/2006/main" xmlns:c="http://schemas.openxmlformats.org/drawingml/2006/chart" xmlns:dgm="http://schemas.openxmlformats.org/drawingml/2006/diagram" xmlns:o="urn:schemas-microsoft-com:office:office" xmlns:v="urn:schemas-microsoft-com:vml" xmlns:pvml="urn:schemas-microsoft-com:office:powerpoint" xmlns:com="http://schemas.openxmlformats.org/drawingml/2006/compatibility" xmlns:p14="http://schemas.microsoft.com/office/powerpoint/2010/main" xmlns:p15="http://schemas.microsoft.com/office/powerpoint/2012/main" xmlns:ahyp="http://schemas.microsoft.com/office/drawing/2018/hyperlinkcolor">
+<p:sld xmlns:a="http://schemas.openxmlformats.org/drawingml/2006/main" xmlns:r="http://schemas.openxmlformats.org/officeDocument/2006/relationships" xmlns:p="http://schemas.openxmlformats.org/presentationml/2006/main">
   <p:cSld>
     <p:spTree>
       <p:nvGrpSpPr>
-        <p:cNvPr id="53" name="Shape 53"/>
+        <p:cNvPr id="1" name="Shape 53"/>
         <p:cNvGrpSpPr/>
         <p:nvPr/>
       </p:nvGrpSpPr>
@@ -5458,7 +5578,9 @@
       <p:sp>
         <p:nvSpPr>
           <p:cNvPr id="54" name="Google Shape;54;p13"/>
-          <p:cNvSpPr txBox="1"/>
+          <p:cNvSpPr txBox="1">
+            <a:spLocks noGrp="1"/>
+          </p:cNvSpPr>
           <p:nvPr>
             <p:ph type="ctrTitle"/>
           </p:nvPr>
@@ -5473,12 +5595,12 @@
           </a:prstGeom>
         </p:spPr>
         <p:txBody>
-          <a:bodyPr anchorCtr="0" anchor="b" bIns="91425" lIns="91425" spcFirstLastPara="1" rIns="91425" wrap="square" tIns="91425">
+          <a:bodyPr spcFirstLastPara="1" wrap="square" lIns="91425" tIns="91425" rIns="91425" bIns="91425" anchor="b" anchorCtr="0">
             <a:normAutofit/>
           </a:bodyPr>
           <a:lstStyle/>
           <a:p>
-            <a:pPr indent="0" lvl="0" marL="0" rtl="0" algn="ctr">
+            <a:pPr marL="0" lvl="0" indent="0" algn="ctr" rtl="0">
               <a:spcBef>
                 <a:spcPts val="0"/>
               </a:spcBef>
@@ -5508,9 +5630,11 @@
       <p:sp>
         <p:nvSpPr>
           <p:cNvPr id="55" name="Google Shape;55;p13"/>
-          <p:cNvSpPr txBox="1"/>
+          <p:cNvSpPr txBox="1">
+            <a:spLocks noGrp="1"/>
+          </p:cNvSpPr>
           <p:nvPr>
-            <p:ph idx="1" type="subTitle"/>
+            <p:ph type="subTitle" idx="1"/>
           </p:nvPr>
         </p:nvSpPr>
         <p:spPr>
@@ -5523,12 +5647,12 @@
           </a:prstGeom>
         </p:spPr>
         <p:txBody>
-          <a:bodyPr anchorCtr="0" anchor="t" bIns="91425" lIns="91425" spcFirstLastPara="1" rIns="91425" wrap="square" tIns="91425">
+          <a:bodyPr spcFirstLastPara="1" wrap="square" lIns="91425" tIns="91425" rIns="91425" bIns="91425" anchor="t" anchorCtr="0">
             <a:normAutofit/>
           </a:bodyPr>
           <a:lstStyle/>
           <a:p>
-            <a:pPr indent="0" lvl="0" marL="0" rtl="0" algn="ctr">
+            <a:pPr marL="0" lvl="0" indent="0" algn="ctr" rtl="0">
               <a:spcBef>
                 <a:spcPts val="0"/>
               </a:spcBef>
@@ -5570,11 +5694,11 @@
 </file>
 
 <file path=ppt/slides/slide2.xml><?xml version="1.0" encoding="utf-8"?>
-<p:sld xmlns:a="http://schemas.openxmlformats.org/drawingml/2006/main" xmlns:r="http://schemas.openxmlformats.org/officeDocument/2006/relationships" xmlns:mc="http://schemas.openxmlformats.org/markup-compatibility/2006" xmlns:mv="urn:schemas-microsoft-com:mac:vml" xmlns:p="http://schemas.openxmlformats.org/presentationml/2006/main" xmlns:c="http://schemas.openxmlformats.org/drawingml/2006/chart" xmlns:dgm="http://schemas.openxmlformats.org/drawingml/2006/diagram" xmlns:o="urn:schemas-microsoft-com:office:office" xmlns:v="urn:schemas-microsoft-com:vml" xmlns:pvml="urn:schemas-microsoft-com:office:powerpoint" xmlns:com="http://schemas.openxmlformats.org/drawingml/2006/compatibility" xmlns:p14="http://schemas.microsoft.com/office/powerpoint/2010/main" xmlns:p15="http://schemas.microsoft.com/office/powerpoint/2012/main" xmlns:ahyp="http://schemas.microsoft.com/office/drawing/2018/hyperlinkcolor">
+<p:sld xmlns:a="http://schemas.openxmlformats.org/drawingml/2006/main" xmlns:r="http://schemas.openxmlformats.org/officeDocument/2006/relationships" xmlns:p="http://schemas.openxmlformats.org/presentationml/2006/main">
   <p:cSld>
     <p:spTree>
       <p:nvGrpSpPr>
-        <p:cNvPr id="59" name="Shape 59"/>
+        <p:cNvPr id="1" name="Shape 59"/>
         <p:cNvGrpSpPr/>
         <p:nvPr/>
       </p:nvGrpSpPr>
@@ -5589,7 +5713,9 @@
       <p:sp>
         <p:nvSpPr>
           <p:cNvPr id="60" name="Google Shape;60;p14"/>
-          <p:cNvSpPr txBox="1"/>
+          <p:cNvSpPr txBox="1">
+            <a:spLocks noGrp="1"/>
+          </p:cNvSpPr>
           <p:nvPr>
             <p:ph type="title"/>
           </p:nvPr>
@@ -5604,12 +5730,12 @@
           </a:prstGeom>
         </p:spPr>
         <p:txBody>
-          <a:bodyPr anchorCtr="0" anchor="t" bIns="91425" lIns="91425" spcFirstLastPara="1" rIns="91425" wrap="square" tIns="91425">
+          <a:bodyPr spcFirstLastPara="1" wrap="square" lIns="91425" tIns="91425" rIns="91425" bIns="91425" anchor="t" anchorCtr="0">
             <a:normAutofit/>
           </a:bodyPr>
           <a:lstStyle/>
           <a:p>
-            <a:pPr indent="0" lvl="0" marL="0" rtl="0" algn="ctr">
+            <a:pPr marL="0" lvl="0" indent="0" algn="ctr" rtl="0">
               <a:spcBef>
                 <a:spcPts val="0"/>
               </a:spcBef>
@@ -5643,7 +5769,7 @@
           <p:nvPr/>
         </p:nvPicPr>
         <p:blipFill>
-          <a:blip r:embed="rId3">
+          <a:blip r:embed="rId2">
             <a:alphaModFix/>
           </a:blip>
           <a:stretch>
@@ -5652,8 +5778,8 @@
         </p:blipFill>
         <p:spPr>
           <a:xfrm>
-            <a:off x="1484038" y="122975"/>
-            <a:ext cx="6175934" cy="4226875"/>
+            <a:off x="1649979" y="156450"/>
+            <a:ext cx="5844041" cy="4226875"/>
           </a:xfrm>
           <a:prstGeom prst="rect">
             <a:avLst/>
@@ -5672,12 +5798,12 @@
 </p:sld>
 </file>
 
-<file path=ppt/slides/slide4.xml><?xml version="1.0" encoding="utf-8"?>
-<p:sld xmlns:a="http://schemas.openxmlformats.org/drawingml/2006/main" xmlns:r="http://schemas.openxmlformats.org/officeDocument/2006/relationships" xmlns:mc="http://schemas.openxmlformats.org/markup-compatibility/2006" xmlns:mv="urn:schemas-microsoft-com:mac:vml" xmlns:p="http://schemas.openxmlformats.org/presentationml/2006/main" xmlns:c="http://schemas.openxmlformats.org/drawingml/2006/chart" xmlns:dgm="http://schemas.openxmlformats.org/drawingml/2006/diagram" xmlns:o="urn:schemas-microsoft-com:office:office" xmlns:v="urn:schemas-microsoft-com:vml" xmlns:pvml="urn:schemas-microsoft-com:office:powerpoint" xmlns:com="http://schemas.openxmlformats.org/drawingml/2006/compatibility" xmlns:p14="http://schemas.microsoft.com/office/powerpoint/2010/main" xmlns:p15="http://schemas.microsoft.com/office/powerpoint/2012/main" xmlns:ahyp="http://schemas.microsoft.com/office/drawing/2018/hyperlinkcolor">
+<file path=ppt/slides/slide3.xml><?xml version="1.0" encoding="utf-8"?>
+<p:sld xmlns:a="http://schemas.openxmlformats.org/drawingml/2006/main" xmlns:r="http://schemas.openxmlformats.org/officeDocument/2006/relationships" xmlns:p="http://schemas.openxmlformats.org/presentationml/2006/main">
   <p:cSld>
     <p:spTree>
       <p:nvGrpSpPr>
-        <p:cNvPr id="59" name="Shape 59"/>
+        <p:cNvPr id="1" name="Shape 59"/>
         <p:cNvGrpSpPr/>
         <p:nvPr/>
       </p:nvGrpSpPr>
@@ -5692,7 +5818,9 @@
       <p:sp>
         <p:nvSpPr>
           <p:cNvPr id="60" name="Google Shape;60;p14"/>
-          <p:cNvSpPr txBox="1"/>
+          <p:cNvSpPr txBox="1">
+            <a:spLocks noGrp="1"/>
+          </p:cNvSpPr>
           <p:nvPr>
             <p:ph type="title"/>
           </p:nvPr>
@@ -5707,12 +5835,12 @@
           </a:prstGeom>
         </p:spPr>
         <p:txBody>
-          <a:bodyPr anchorCtr="0" anchor="t" bIns="91425" lIns="91425" spcFirstLastPara="1" rIns="91425" wrap="square" tIns="91425">
+          <a:bodyPr spcFirstLastPara="1" wrap="square" lIns="91425" tIns="91425" rIns="91425" bIns="91425" anchor="t" anchorCtr="0">
             <a:normAutofit/>
           </a:bodyPr>
           <a:lstStyle/>
           <a:p>
-            <a:pPr indent="0" lvl="0" marL="0" rtl="0" algn="ctr">
+            <a:pPr marL="0" lvl="0" indent="0" algn="ctr" rtl="0">
               <a:spcBef>
                 <a:spcPts val="0"/>
               </a:spcBef>
@@ -5746,7 +5874,7 @@
           <p:nvPr/>
         </p:nvPicPr>
         <p:blipFill>
-          <a:blip r:embed="rId3">
+          <a:blip r:embed="rId2">
             <a:alphaModFix/>
           </a:blip>
           <a:stretch>
@@ -5755,8 +5883,8 @@
         </p:blipFill>
         <p:spPr>
           <a:xfrm>
-            <a:off x="1484038" y="122975"/>
-            <a:ext cx="6175934" cy="4226875"/>
+            <a:off x="1682176" y="156450"/>
+            <a:ext cx="5779647" cy="4226875"/>
           </a:xfrm>
           <a:prstGeom prst="rect">
             <a:avLst/>
@@ -5775,12 +5903,12 @@
 </p:sld>
 </file>
 
-<file path=ppt/slides/slide5.xml><?xml version="1.0" encoding="utf-8"?>
-<p:sld xmlns:a="http://schemas.openxmlformats.org/drawingml/2006/main" xmlns:r="http://schemas.openxmlformats.org/officeDocument/2006/relationships" xmlns:mc="http://schemas.openxmlformats.org/markup-compatibility/2006" xmlns:mv="urn:schemas-microsoft-com:mac:vml" xmlns:p="http://schemas.openxmlformats.org/presentationml/2006/main" xmlns:c="http://schemas.openxmlformats.org/drawingml/2006/chart" xmlns:dgm="http://schemas.openxmlformats.org/drawingml/2006/diagram" xmlns:o="urn:schemas-microsoft-com:office:office" xmlns:v="urn:schemas-microsoft-com:vml" xmlns:pvml="urn:schemas-microsoft-com:office:powerpoint" xmlns:com="http://schemas.openxmlformats.org/drawingml/2006/compatibility" xmlns:p14="http://schemas.microsoft.com/office/powerpoint/2010/main" xmlns:p15="http://schemas.microsoft.com/office/powerpoint/2012/main" xmlns:ahyp="http://schemas.microsoft.com/office/drawing/2018/hyperlinkcolor">
+<file path=ppt/slides/slide4.xml><?xml version="1.0" encoding="utf-8"?>
+<p:sld xmlns:a="http://schemas.openxmlformats.org/drawingml/2006/main" xmlns:r="http://schemas.openxmlformats.org/officeDocument/2006/relationships" xmlns:p="http://schemas.openxmlformats.org/presentationml/2006/main">
   <p:cSld>
     <p:spTree>
       <p:nvGrpSpPr>
-        <p:cNvPr id="59" name="Shape 59"/>
+        <p:cNvPr id="1" name="Shape 59"/>
         <p:cNvGrpSpPr/>
         <p:nvPr/>
       </p:nvGrpSpPr>
@@ -5795,7 +5923,9 @@
       <p:sp>
         <p:nvSpPr>
           <p:cNvPr id="60" name="Google Shape;60;p14"/>
-          <p:cNvSpPr txBox="1"/>
+          <p:cNvSpPr txBox="1">
+            <a:spLocks noGrp="1"/>
+          </p:cNvSpPr>
           <p:nvPr>
             <p:ph type="title"/>
           </p:nvPr>
@@ -5810,12 +5940,12 @@
           </a:prstGeom>
         </p:spPr>
         <p:txBody>
-          <a:bodyPr anchorCtr="0" anchor="t" bIns="91425" lIns="91425" spcFirstLastPara="1" rIns="91425" wrap="square" tIns="91425">
+          <a:bodyPr spcFirstLastPara="1" wrap="square" lIns="91425" tIns="91425" rIns="91425" bIns="91425" anchor="t" anchorCtr="0">
             <a:normAutofit/>
           </a:bodyPr>
           <a:lstStyle/>
           <a:p>
-            <a:pPr indent="0" lvl="0" marL="0" rtl="0" algn="ctr">
+            <a:pPr marL="0" lvl="0" indent="0" algn="ctr" rtl="0">
               <a:spcBef>
                 <a:spcPts val="0"/>
               </a:spcBef>
@@ -5849,7 +5979,7 @@
           <p:nvPr/>
         </p:nvPicPr>
         <p:blipFill>
-          <a:blip r:embed="rId3">
+          <a:blip r:embed="rId2">
             <a:alphaModFix/>
           </a:blip>
           <a:stretch>
@@ -5858,8 +5988,8 @@
         </p:blipFill>
         <p:spPr>
           <a:xfrm>
-            <a:off x="1484038" y="122975"/>
-            <a:ext cx="6175934" cy="4226875"/>
+            <a:off x="2332560" y="156450"/>
+            <a:ext cx="4478880" cy="4226875"/>
           </a:xfrm>
           <a:prstGeom prst="rect">
             <a:avLst/>
@@ -5878,12 +6008,12 @@
 </p:sld>
 </file>
 
-<file path=ppt/slides/slide6.xml><?xml version="1.0" encoding="utf-8"?>
-<p:sld xmlns:a="http://schemas.openxmlformats.org/drawingml/2006/main" xmlns:r="http://schemas.openxmlformats.org/officeDocument/2006/relationships" xmlns:mc="http://schemas.openxmlformats.org/markup-compatibility/2006" xmlns:mv="urn:schemas-microsoft-com:mac:vml" xmlns:p="http://schemas.openxmlformats.org/presentationml/2006/main" xmlns:c="http://schemas.openxmlformats.org/drawingml/2006/chart" xmlns:dgm="http://schemas.openxmlformats.org/drawingml/2006/diagram" xmlns:o="urn:schemas-microsoft-com:office:office" xmlns:v="urn:schemas-microsoft-com:vml" xmlns:pvml="urn:schemas-microsoft-com:office:powerpoint" xmlns:com="http://schemas.openxmlformats.org/drawingml/2006/compatibility" xmlns:p14="http://schemas.microsoft.com/office/powerpoint/2010/main" xmlns:p15="http://schemas.microsoft.com/office/powerpoint/2012/main" xmlns:ahyp="http://schemas.microsoft.com/office/drawing/2018/hyperlinkcolor">
+<file path=ppt/slides/slide5.xml><?xml version="1.0" encoding="utf-8"?>
+<p:sld xmlns:a="http://schemas.openxmlformats.org/drawingml/2006/main" xmlns:r="http://schemas.openxmlformats.org/officeDocument/2006/relationships" xmlns:p="http://schemas.openxmlformats.org/presentationml/2006/main">
   <p:cSld>
     <p:spTree>
       <p:nvGrpSpPr>
-        <p:cNvPr id="59" name="Shape 59"/>
+        <p:cNvPr id="1" name="Shape 59"/>
         <p:cNvGrpSpPr/>
         <p:nvPr/>
       </p:nvGrpSpPr>
@@ -5898,7 +6028,9 @@
       <p:sp>
         <p:nvSpPr>
           <p:cNvPr id="60" name="Google Shape;60;p14"/>
-          <p:cNvSpPr txBox="1"/>
+          <p:cNvSpPr txBox="1">
+            <a:spLocks noGrp="1"/>
+          </p:cNvSpPr>
           <p:nvPr>
             <p:ph type="title"/>
           </p:nvPr>
@@ -5913,12 +6045,12 @@
           </a:prstGeom>
         </p:spPr>
         <p:txBody>
-          <a:bodyPr anchorCtr="0" anchor="t" bIns="91425" lIns="91425" spcFirstLastPara="1" rIns="91425" wrap="square" tIns="91425">
+          <a:bodyPr spcFirstLastPara="1" wrap="square" lIns="91425" tIns="91425" rIns="91425" bIns="91425" anchor="t" anchorCtr="0">
             <a:normAutofit/>
           </a:bodyPr>
           <a:lstStyle/>
           <a:p>
-            <a:pPr indent="0" lvl="0" marL="0" rtl="0" algn="ctr">
+            <a:pPr marL="0" lvl="0" indent="0" algn="ctr" rtl="0">
               <a:spcBef>
                 <a:spcPts val="0"/>
               </a:spcBef>
@@ -5952,7 +6084,7 @@
           <p:nvPr/>
         </p:nvPicPr>
         <p:blipFill>
-          <a:blip r:embed="rId3">
+          <a:blip r:embed="rId2">
             <a:alphaModFix/>
           </a:blip>
           <a:stretch>
@@ -5961,8 +6093,8 @@
         </p:blipFill>
         <p:spPr>
           <a:xfrm>
-            <a:off x="1484038" y="122975"/>
-            <a:ext cx="6175934" cy="4226875"/>
+            <a:off x="1656419" y="156450"/>
+            <a:ext cx="5831162" cy="4226875"/>
           </a:xfrm>
           <a:prstGeom prst="rect">
             <a:avLst/>
@@ -5982,7 +6114,7 @@
 </file>
 
 <file path=ppt/theme/theme1.xml><?xml version="1.0" encoding="utf-8"?>
-<a:theme xmlns:a="http://schemas.openxmlformats.org/drawingml/2006/main" xmlns:r="http://schemas.openxmlformats.org/officeDocument/2006/relationships" name="Simple Light">
+<a:theme xmlns:a="http://schemas.openxmlformats.org/drawingml/2006/main" name="Simple Light">
   <a:themeElements>
     <a:clrScheme name="Simple Light">
       <a:dk1>
@@ -6257,11 +6389,13 @@
       </a:bgFillStyleLst>
     </a:fmtScheme>
   </a:themeElements>
+  <a:objectDefaults/>
+  <a:extraClrSchemeLst/>
 </a:theme>
 </file>
 
 <file path=ppt/theme/theme2.xml><?xml version="1.0" encoding="utf-8"?>
-<a:theme xmlns:a="http://schemas.openxmlformats.org/drawingml/2006/main" xmlns:r="http://schemas.openxmlformats.org/officeDocument/2006/relationships">
+<a:theme xmlns:a="http://schemas.openxmlformats.org/drawingml/2006/main">
   <a:themeElements>
     <a:clrScheme name="Default">
       <a:dk1>
@@ -6536,5 +6670,7 @@
       </a:bgFillStyleLst>
     </a:fmtScheme>
   </a:themeElements>
+  <a:objectDefaults/>
+  <a:extraClrSchemeLst/>
 </a:theme>
 </file>
</xml_diff>